<commit_message>
docs(navigation): update the web and mobile navigation maps and add their sources
</commit_message>
<xml_diff>
--- a/Diagramas de navegación/Mapa de navegación movil.pptx
+++ b/Diagramas de navegación/Mapa de navegación movil.pptx
@@ -3349,35 +3349,38 @@
       </p:grpSpPr>
       <p:sp>
         <p:nvSpPr>
-          <p:cNvPr id="4" name="Rectángulo 3">
-            <a:extLst>
-              <a:ext uri="{FF2B5EF4-FFF2-40B4-BE49-F238E27FC236}">
-                <a16:creationId xmlns:a16="http://schemas.microsoft.com/office/drawing/2014/main" id="{A4AACA20-73AD-17B0-4BD2-AA69AF4ED629}"/>
-              </a:ext>
-            </a:extLst>
-          </p:cNvPr>
+          <p:cNvPr id="2" name="Rounded Rectangle 1"/>
           <p:cNvSpPr/>
           <p:nvPr/>
         </p:nvSpPr>
         <p:spPr>
           <a:xfrm>
-            <a:off x="5097809" y="1275256"/>
-            <a:ext cx="1996382" cy="328246"/>
-          </a:xfrm>
-          <a:prstGeom prst="rect">
-            <a:avLst/>
-          </a:prstGeom>
+            <a:off x="228600" y="137160"/>
+            <a:ext cx="11704320" cy="566928"/>
+          </a:xfrm>
+          <a:prstGeom prst="roundRect">
+            <a:avLst>
+              <a:gd name="adj" fmla="val 14000"/>
+            </a:avLst>
+          </a:prstGeom>
+          <a:solidFill>
+            <a:srgbClr val="1F4E79"/>
+          </a:solidFill>
+          <a:ln w="12700">
+            <a:solidFill>
+              <a:srgbClr val="1F4E79"/>
+            </a:solidFill>
+          </a:ln>
+          <a:effectLst/>
         </p:spPr>
         <p:style>
-          <a:lnRef idx="2">
-            <a:schemeClr val="accent1">
-              <a:shade val="15000"/>
-            </a:schemeClr>
+          <a:lnRef idx="1">
+            <a:schemeClr val="accent1"/>
           </a:lnRef>
-          <a:fillRef idx="1">
+          <a:fillRef idx="3">
             <a:schemeClr val="accent1"/>
           </a:fillRef>
-          <a:effectRef idx="0">
+          <a:effectRef idx="2">
             <a:schemeClr val="accent1"/>
           </a:effectRef>
           <a:fontRef idx="minor">
@@ -3385,63 +3388,66 @@
           </a:fontRef>
         </p:style>
         <p:txBody>
-          <a:bodyPr rtlCol="0" anchor="ctr"/>
+          <a:bodyPr rtlCol="0" anchor="ctr" wrap="square" lIns="25400" rIns="25400" tIns="0" bIns="0"/>
           <a:lstStyle/>
           <a:p>
             <a:pPr algn="ctr"/>
             <a:r>
-              <a:rPr lang="es-MX" sz="1600" dirty="0">
-                <a:latin typeface="Arial" panose="020B0604020202020204" pitchFamily="34" charset="0"/>
-                <a:cs typeface="Arial" panose="020B0604020202020204" pitchFamily="34" charset="0"/>
+              <a:rPr sz="1900" b="1">
+                <a:solidFill>
+                  <a:srgbClr val="FFFFFF"/>
+                </a:solidFill>
               </a:rPr>
-              <a:t>Menú desplegable</a:t>
-            </a:r>
-            <a:endParaRPr lang="es-CO" sz="1600" dirty="0">
-              <a:latin typeface="Arial" panose="020B0604020202020204" pitchFamily="34" charset="0"/>
-              <a:cs typeface="Arial" panose="020B0604020202020204" pitchFamily="34" charset="0"/>
-            </a:endParaRPr>
-          </a:p>
-        </p:txBody>
-      </p:sp>
-      <p:sp>
-        <p:nvSpPr>
-          <p:cNvPr id="6" name="Rectángulo 5">
-            <a:extLst>
-              <a:ext uri="{FF2B5EF4-FFF2-40B4-BE49-F238E27FC236}">
-                <a16:creationId xmlns:a16="http://schemas.microsoft.com/office/drawing/2014/main" id="{8D994591-036E-8325-4BC3-7D82DB13A275}"/>
-              </a:ext>
-            </a:extLst>
-          </p:cNvPr>
+              <a:t>EnergyMonitor — Mapa de navegación (Móvil)</a:t>
+            </a:r>
+          </a:p>
+          <a:p>
+            <a:pPr algn="ctr"/>
+            <a:r>
+              <a:rPr sz="1000">
+                <a:solidFill>
+                  <a:srgbClr val="D6E4F7"/>
+                </a:solidFill>
+              </a:rPr>
+              <a:t>Navegación por menú desplegable (hamburguesa). Tras iniciar sesión se accede a Inicio (Dashboard).</a:t>
+            </a:r>
+          </a:p>
+        </p:txBody>
+      </p:sp>
+      <p:sp>
+        <p:nvSpPr>
+          <p:cNvPr id="3" name="Rounded Rectangle 2"/>
           <p:cNvSpPr/>
           <p:nvPr/>
         </p:nvSpPr>
         <p:spPr>
           <a:xfrm>
-            <a:off x="2642846" y="1992922"/>
-            <a:ext cx="1655881" cy="213945"/>
-          </a:xfrm>
-          <a:prstGeom prst="rect">
-            <a:avLst/>
+            <a:off x="228600" y="896112"/>
+            <a:ext cx="1600200" cy="457200"/>
+          </a:xfrm>
+          <a:prstGeom prst="roundRect">
+            <a:avLst>
+              <a:gd name="adj" fmla="val 14000"/>
+            </a:avLst>
           </a:prstGeom>
           <a:solidFill>
-            <a:schemeClr val="accent1"/>
+            <a:srgbClr val="1F4E79"/>
           </a:solidFill>
-          <a:ln>
+          <a:ln w="12700">
             <a:solidFill>
-              <a:schemeClr val="tx1"/>
+              <a:srgbClr val="1F4E79"/>
             </a:solidFill>
           </a:ln>
+          <a:effectLst/>
         </p:spPr>
         <p:style>
-          <a:lnRef idx="2">
-            <a:schemeClr val="accent1">
-              <a:shade val="15000"/>
-            </a:schemeClr>
+          <a:lnRef idx="1">
+            <a:schemeClr val="accent1"/>
           </a:lnRef>
-          <a:fillRef idx="1">
+          <a:fillRef idx="3">
             <a:schemeClr val="accent1"/>
           </a:fillRef>
-          <a:effectRef idx="0">
+          <a:effectRef idx="2">
             <a:schemeClr val="accent1"/>
           </a:effectRef>
           <a:fontRef idx="minor">
@@ -3449,539 +3455,40 @@
           </a:fontRef>
         </p:style>
         <p:txBody>
-          <a:bodyPr rtlCol="0" anchor="ctr"/>
+          <a:bodyPr rtlCol="0" anchor="ctr" wrap="square" lIns="25400" rIns="25400" tIns="0" bIns="0"/>
           <a:lstStyle/>
           <a:p>
             <a:pPr algn="ctr"/>
             <a:r>
-              <a:rPr lang="es-MX" sz="1200" dirty="0">
+              <a:rPr sz="1100" b="1">
                 <a:solidFill>
-                  <a:schemeClr val="bg1"/>
+                  <a:srgbClr val="FFFFFF"/>
                 </a:solidFill>
-                <a:latin typeface="Arial" panose="020B0604020202020204" pitchFamily="34" charset="0"/>
-                <a:cs typeface="Arial" panose="020B0604020202020204" pitchFamily="34" charset="0"/>
               </a:rPr>
-              <a:t>Consultar Consumo</a:t>
-            </a:r>
-            <a:endParaRPr lang="es-CO" sz="1200" dirty="0">
-              <a:solidFill>
-                <a:schemeClr val="bg1"/>
-              </a:solidFill>
-              <a:latin typeface="Arial" panose="020B0604020202020204" pitchFamily="34" charset="0"/>
-              <a:cs typeface="Arial" panose="020B0604020202020204" pitchFamily="34" charset="0"/>
-            </a:endParaRPr>
-          </a:p>
-        </p:txBody>
-      </p:sp>
-      <p:sp>
-        <p:nvSpPr>
-          <p:cNvPr id="20" name="Rectángulo 19">
-            <a:extLst>
-              <a:ext uri="{FF2B5EF4-FFF2-40B4-BE49-F238E27FC236}">
-                <a16:creationId xmlns:a16="http://schemas.microsoft.com/office/drawing/2014/main" id="{E24D6FF9-9D9D-F7D9-1FAB-6BFBC6E97C58}"/>
-              </a:ext>
-            </a:extLst>
-          </p:cNvPr>
-          <p:cNvSpPr/>
-          <p:nvPr/>
-        </p:nvSpPr>
-        <p:spPr>
-          <a:xfrm>
-            <a:off x="773002" y="1992923"/>
-            <a:ext cx="1488824" cy="213946"/>
-          </a:xfrm>
-          <a:prstGeom prst="rect">
-            <a:avLst/>
-          </a:prstGeom>
-        </p:spPr>
-        <p:style>
-          <a:lnRef idx="2">
-            <a:schemeClr val="accent1">
-              <a:shade val="15000"/>
-            </a:schemeClr>
-          </a:lnRef>
-          <a:fillRef idx="1">
-            <a:schemeClr val="accent1"/>
-          </a:fillRef>
-          <a:effectRef idx="0">
-            <a:schemeClr val="accent1"/>
-          </a:effectRef>
-          <a:fontRef idx="minor">
-            <a:schemeClr val="lt1"/>
-          </a:fontRef>
-        </p:style>
-        <p:txBody>
-          <a:bodyPr rtlCol="0" anchor="ctr"/>
-          <a:lstStyle/>
-          <a:p>
-            <a:pPr algn="ctr"/>
-            <a:r>
-              <a:rPr lang="es-MX" sz="1200" dirty="0">
-                <a:latin typeface="Arial" panose="020B0604020202020204" pitchFamily="34" charset="0"/>
-                <a:cs typeface="Arial" panose="020B0604020202020204" pitchFamily="34" charset="0"/>
-              </a:rPr>
-              <a:t>Iniciar Sesión</a:t>
-            </a:r>
-            <a:endParaRPr lang="es-CO" sz="1200" dirty="0">
-              <a:latin typeface="Arial" panose="020B0604020202020204" pitchFamily="34" charset="0"/>
-              <a:cs typeface="Arial" panose="020B0604020202020204" pitchFamily="34" charset="0"/>
-            </a:endParaRPr>
-          </a:p>
-        </p:txBody>
-      </p:sp>
-      <p:sp>
-        <p:nvSpPr>
-          <p:cNvPr id="29" name="Rectángulo 28">
-            <a:extLst>
-              <a:ext uri="{FF2B5EF4-FFF2-40B4-BE49-F238E27FC236}">
-                <a16:creationId xmlns:a16="http://schemas.microsoft.com/office/drawing/2014/main" id="{9C922FF0-90BF-7DA5-7888-79FAD1C1E772}"/>
-              </a:ext>
-            </a:extLst>
-          </p:cNvPr>
-          <p:cNvSpPr/>
-          <p:nvPr/>
-        </p:nvSpPr>
-        <p:spPr>
-          <a:xfrm>
-            <a:off x="4679747" y="1992922"/>
-            <a:ext cx="1249965" cy="213945"/>
-          </a:xfrm>
-          <a:prstGeom prst="rect">
-            <a:avLst/>
-          </a:prstGeom>
-        </p:spPr>
-        <p:style>
-          <a:lnRef idx="2">
-            <a:schemeClr val="accent1">
-              <a:shade val="15000"/>
-            </a:schemeClr>
-          </a:lnRef>
-          <a:fillRef idx="1">
-            <a:schemeClr val="accent1"/>
-          </a:fillRef>
-          <a:effectRef idx="0">
-            <a:schemeClr val="accent1"/>
-          </a:effectRef>
-          <a:fontRef idx="minor">
-            <a:schemeClr val="lt1"/>
-          </a:fontRef>
-        </p:style>
-        <p:txBody>
-          <a:bodyPr rtlCol="0" anchor="ctr"/>
-          <a:lstStyle/>
-          <a:p>
-            <a:pPr algn="ctr"/>
-            <a:r>
-              <a:rPr lang="es-MX" sz="1200" dirty="0">
-                <a:latin typeface="Arial" panose="020B0604020202020204" pitchFamily="34" charset="0"/>
-                <a:cs typeface="Arial" panose="020B0604020202020204" pitchFamily="34" charset="0"/>
-              </a:rPr>
-              <a:t>Alertas</a:t>
-            </a:r>
-            <a:endParaRPr lang="es-CO" sz="1200" dirty="0">
-              <a:latin typeface="Arial" panose="020B0604020202020204" pitchFamily="34" charset="0"/>
-              <a:cs typeface="Arial" panose="020B0604020202020204" pitchFamily="34" charset="0"/>
-            </a:endParaRPr>
-          </a:p>
-        </p:txBody>
-      </p:sp>
-      <p:sp>
-        <p:nvSpPr>
-          <p:cNvPr id="9" name="Rectángulo 8">
-            <a:extLst>
-              <a:ext uri="{FF2B5EF4-FFF2-40B4-BE49-F238E27FC236}">
-                <a16:creationId xmlns:a16="http://schemas.microsoft.com/office/drawing/2014/main" id="{2AB68512-F7C0-9A6C-0129-0DD97228D538}"/>
-              </a:ext>
-            </a:extLst>
-          </p:cNvPr>
-          <p:cNvSpPr/>
-          <p:nvPr/>
-        </p:nvSpPr>
-        <p:spPr>
-          <a:xfrm>
-            <a:off x="6310732" y="1992921"/>
-            <a:ext cx="1488824" cy="213946"/>
-          </a:xfrm>
-          <a:prstGeom prst="rect">
-            <a:avLst/>
-          </a:prstGeom>
-        </p:spPr>
-        <p:style>
-          <a:lnRef idx="2">
-            <a:schemeClr val="accent1">
-              <a:shade val="15000"/>
-            </a:schemeClr>
-          </a:lnRef>
-          <a:fillRef idx="1">
-            <a:schemeClr val="accent1"/>
-          </a:fillRef>
-          <a:effectRef idx="0">
-            <a:schemeClr val="accent1"/>
-          </a:effectRef>
-          <a:fontRef idx="minor">
-            <a:schemeClr val="lt1"/>
-          </a:fontRef>
-        </p:style>
-        <p:txBody>
-          <a:bodyPr rtlCol="0" anchor="ctr"/>
-          <a:lstStyle/>
-          <a:p>
-            <a:pPr algn="ctr"/>
-            <a:r>
-              <a:rPr lang="es-MX" sz="1200" dirty="0">
-                <a:latin typeface="Arial" panose="020B0604020202020204" pitchFamily="34" charset="0"/>
-                <a:cs typeface="Arial" panose="020B0604020202020204" pitchFamily="34" charset="0"/>
-              </a:rPr>
-              <a:t>Recomendaciones</a:t>
-            </a:r>
-            <a:endParaRPr lang="es-CO" sz="1200" dirty="0">
-              <a:latin typeface="Arial" panose="020B0604020202020204" pitchFamily="34" charset="0"/>
-              <a:cs typeface="Arial" panose="020B0604020202020204" pitchFamily="34" charset="0"/>
-            </a:endParaRPr>
-          </a:p>
-        </p:txBody>
-      </p:sp>
-      <p:sp>
-        <p:nvSpPr>
-          <p:cNvPr id="15" name="Rectángulo 14">
-            <a:extLst>
-              <a:ext uri="{FF2B5EF4-FFF2-40B4-BE49-F238E27FC236}">
-                <a16:creationId xmlns:a16="http://schemas.microsoft.com/office/drawing/2014/main" id="{14ADC930-6276-0E10-0EF3-7E22DDB3C6F6}"/>
-              </a:ext>
-            </a:extLst>
-          </p:cNvPr>
-          <p:cNvSpPr/>
-          <p:nvPr/>
-        </p:nvSpPr>
-        <p:spPr>
-          <a:xfrm>
-            <a:off x="8180576" y="1992921"/>
-            <a:ext cx="1036743" cy="213946"/>
-          </a:xfrm>
-          <a:prstGeom prst="rect">
-            <a:avLst/>
-          </a:prstGeom>
-          <a:ln>
-            <a:solidFill>
-              <a:srgbClr val="FF0000"/>
-            </a:solidFill>
-          </a:ln>
-        </p:spPr>
-        <p:style>
-          <a:lnRef idx="2">
-            <a:schemeClr val="accent1">
-              <a:shade val="15000"/>
-            </a:schemeClr>
-          </a:lnRef>
-          <a:fillRef idx="1">
-            <a:schemeClr val="accent1"/>
-          </a:fillRef>
-          <a:effectRef idx="0">
-            <a:schemeClr val="accent1"/>
-          </a:effectRef>
-          <a:fontRef idx="minor">
-            <a:schemeClr val="lt1"/>
-          </a:fontRef>
-        </p:style>
-        <p:txBody>
-          <a:bodyPr rtlCol="0" anchor="ctr"/>
-          <a:lstStyle/>
-          <a:p>
-            <a:pPr algn="ctr"/>
-            <a:r>
-              <a:rPr lang="es-MX" sz="1200" dirty="0">
-                <a:latin typeface="Arial" panose="020B0604020202020204" pitchFamily="34" charset="0"/>
-                <a:cs typeface="Arial" panose="020B0604020202020204" pitchFamily="34" charset="0"/>
-              </a:rPr>
-              <a:t>Proyectos</a:t>
-            </a:r>
-            <a:endParaRPr lang="es-CO" sz="1200" dirty="0">
-              <a:latin typeface="Arial" panose="020B0604020202020204" pitchFamily="34" charset="0"/>
-              <a:cs typeface="Arial" panose="020B0604020202020204" pitchFamily="34" charset="0"/>
-            </a:endParaRPr>
-          </a:p>
-        </p:txBody>
-      </p:sp>
-      <p:sp>
-        <p:nvSpPr>
-          <p:cNvPr id="17" name="Rectángulo 16">
-            <a:extLst>
-              <a:ext uri="{FF2B5EF4-FFF2-40B4-BE49-F238E27FC236}">
-                <a16:creationId xmlns:a16="http://schemas.microsoft.com/office/drawing/2014/main" id="{8B15DBAA-E44F-239F-DC4A-1484D2183DCC}"/>
-              </a:ext>
-            </a:extLst>
-          </p:cNvPr>
-          <p:cNvSpPr/>
-          <p:nvPr/>
-        </p:nvSpPr>
-        <p:spPr>
-          <a:xfrm>
-            <a:off x="9549154" y="1992921"/>
-            <a:ext cx="1655881" cy="213946"/>
-          </a:xfrm>
-          <a:prstGeom prst="rect">
-            <a:avLst/>
-          </a:prstGeom>
-        </p:spPr>
-        <p:style>
-          <a:lnRef idx="2">
-            <a:schemeClr val="accent1">
-              <a:shade val="15000"/>
-            </a:schemeClr>
-          </a:lnRef>
-          <a:fillRef idx="1">
-            <a:schemeClr val="accent1"/>
-          </a:fillRef>
-          <a:effectRef idx="0">
-            <a:schemeClr val="accent1"/>
-          </a:effectRef>
-          <a:fontRef idx="minor">
-            <a:schemeClr val="lt1"/>
-          </a:fontRef>
-        </p:style>
-        <p:txBody>
-          <a:bodyPr rtlCol="0" anchor="ctr"/>
-          <a:lstStyle/>
-          <a:p>
-            <a:pPr algn="ctr"/>
-            <a:r>
-              <a:rPr lang="es-MX" sz="1200" dirty="0">
-                <a:latin typeface="Arial" panose="020B0604020202020204" pitchFamily="34" charset="0"/>
-                <a:cs typeface="Arial" panose="020B0604020202020204" pitchFamily="34" charset="0"/>
-              </a:rPr>
-              <a:t>Gestión del sistema</a:t>
-            </a:r>
-            <a:endParaRPr lang="es-CO" sz="1200" dirty="0">
-              <a:latin typeface="Arial" panose="020B0604020202020204" pitchFamily="34" charset="0"/>
-              <a:cs typeface="Arial" panose="020B0604020202020204" pitchFamily="34" charset="0"/>
-            </a:endParaRPr>
-          </a:p>
-        </p:txBody>
-      </p:sp>
-      <p:sp>
-        <p:nvSpPr>
-          <p:cNvPr id="27" name="Rectángulo 26">
-            <a:extLst>
-              <a:ext uri="{FF2B5EF4-FFF2-40B4-BE49-F238E27FC236}">
-                <a16:creationId xmlns:a16="http://schemas.microsoft.com/office/drawing/2014/main" id="{427C3096-C4D1-EDAA-3C2C-CFAC5F4672EE}"/>
-              </a:ext>
-            </a:extLst>
-          </p:cNvPr>
-          <p:cNvSpPr/>
-          <p:nvPr/>
-        </p:nvSpPr>
-        <p:spPr>
-          <a:xfrm>
-            <a:off x="424414" y="4854818"/>
-            <a:ext cx="1116823" cy="366345"/>
-          </a:xfrm>
-          <a:prstGeom prst="rect">
-            <a:avLst/>
-          </a:prstGeom>
-          <a:solidFill>
-            <a:schemeClr val="bg1"/>
-          </a:solidFill>
-        </p:spPr>
-        <p:style>
-          <a:lnRef idx="2">
-            <a:schemeClr val="accent1">
-              <a:shade val="15000"/>
-            </a:schemeClr>
-          </a:lnRef>
-          <a:fillRef idx="1">
-            <a:schemeClr val="accent1"/>
-          </a:fillRef>
-          <a:effectRef idx="0">
-            <a:schemeClr val="accent1"/>
-          </a:effectRef>
-          <a:fontRef idx="minor">
-            <a:schemeClr val="lt1"/>
-          </a:fontRef>
-        </p:style>
-        <p:txBody>
-          <a:bodyPr rtlCol="0" anchor="ctr"/>
-          <a:lstStyle/>
-          <a:p>
-            <a:pPr algn="ctr"/>
-            <a:r>
-              <a:rPr lang="es-MX" sz="1200" dirty="0">
-                <a:solidFill>
-                  <a:schemeClr val="tx1"/>
-                </a:solidFill>
-                <a:latin typeface="Arial" panose="020B0604020202020204" pitchFamily="34" charset="0"/>
-                <a:cs typeface="Arial" panose="020B0604020202020204" pitchFamily="34" charset="0"/>
-              </a:rPr>
-              <a:t>Registrarse</a:t>
-            </a:r>
-            <a:endParaRPr lang="es-CO" sz="1200" dirty="0">
-              <a:solidFill>
-                <a:schemeClr val="tx1"/>
-              </a:solidFill>
-              <a:latin typeface="Arial" panose="020B0604020202020204" pitchFamily="34" charset="0"/>
-              <a:cs typeface="Arial" panose="020B0604020202020204" pitchFamily="34" charset="0"/>
-            </a:endParaRPr>
-          </a:p>
-        </p:txBody>
-      </p:sp>
-      <p:sp>
-        <p:nvSpPr>
-          <p:cNvPr id="28" name="Rectángulo 27">
-            <a:extLst>
-              <a:ext uri="{FF2B5EF4-FFF2-40B4-BE49-F238E27FC236}">
-                <a16:creationId xmlns:a16="http://schemas.microsoft.com/office/drawing/2014/main" id="{2AAB0CED-8463-BD98-0102-9ADE175C3C12}"/>
-              </a:ext>
-            </a:extLst>
-          </p:cNvPr>
-          <p:cNvSpPr/>
-          <p:nvPr/>
-        </p:nvSpPr>
-        <p:spPr>
-          <a:xfrm>
-            <a:off x="1828264" y="4854820"/>
-            <a:ext cx="1856470" cy="366346"/>
-          </a:xfrm>
-          <a:prstGeom prst="rect">
-            <a:avLst/>
-          </a:prstGeom>
-          <a:solidFill>
-            <a:schemeClr val="bg1"/>
-          </a:solidFill>
-        </p:spPr>
-        <p:style>
-          <a:lnRef idx="2">
-            <a:schemeClr val="accent1">
-              <a:shade val="15000"/>
-            </a:schemeClr>
-          </a:lnRef>
-          <a:fillRef idx="1">
-            <a:schemeClr val="accent1"/>
-          </a:fillRef>
-          <a:effectRef idx="0">
-            <a:schemeClr val="accent1"/>
-          </a:effectRef>
-          <a:fontRef idx="minor">
-            <a:schemeClr val="lt1"/>
-          </a:fontRef>
-        </p:style>
-        <p:txBody>
-          <a:bodyPr rtlCol="0" anchor="ctr"/>
-          <a:lstStyle/>
-          <a:p>
-            <a:pPr algn="ctr"/>
-            <a:r>
-              <a:rPr lang="es-MX" sz="1200" dirty="0">
-                <a:solidFill>
-                  <a:schemeClr val="tx1"/>
-                </a:solidFill>
-                <a:latin typeface="Arial" panose="020B0604020202020204" pitchFamily="34" charset="0"/>
-                <a:cs typeface="Arial" panose="020B0604020202020204" pitchFamily="34" charset="0"/>
-              </a:rPr>
-              <a:t>Registrarse con redes sociales</a:t>
-            </a:r>
-            <a:endParaRPr lang="es-CO" sz="1200" dirty="0">
-              <a:solidFill>
-                <a:schemeClr val="tx1"/>
-              </a:solidFill>
-              <a:latin typeface="Arial" panose="020B0604020202020204" pitchFamily="34" charset="0"/>
-              <a:cs typeface="Arial" panose="020B0604020202020204" pitchFamily="34" charset="0"/>
-            </a:endParaRPr>
-          </a:p>
-        </p:txBody>
-      </p:sp>
-      <p:sp>
-        <p:nvSpPr>
-          <p:cNvPr id="31" name="Rectángulo 30">
-            <a:extLst>
-              <a:ext uri="{FF2B5EF4-FFF2-40B4-BE49-F238E27FC236}">
-                <a16:creationId xmlns:a16="http://schemas.microsoft.com/office/drawing/2014/main" id="{481D3C53-0727-B38D-E95C-36EC38A419C1}"/>
-              </a:ext>
-            </a:extLst>
-          </p:cNvPr>
-          <p:cNvSpPr/>
-          <p:nvPr/>
-        </p:nvSpPr>
-        <p:spPr>
-          <a:xfrm>
-            <a:off x="3981121" y="4865077"/>
-            <a:ext cx="1711185" cy="366346"/>
-          </a:xfrm>
-          <a:prstGeom prst="rect">
-            <a:avLst/>
-          </a:prstGeom>
-          <a:solidFill>
-            <a:schemeClr val="bg1"/>
-          </a:solidFill>
-        </p:spPr>
-        <p:style>
-          <a:lnRef idx="2">
-            <a:schemeClr val="accent1">
-              <a:shade val="15000"/>
-            </a:schemeClr>
-          </a:lnRef>
-          <a:fillRef idx="1">
-            <a:schemeClr val="accent1"/>
-          </a:fillRef>
-          <a:effectRef idx="0">
-            <a:schemeClr val="accent1"/>
-          </a:effectRef>
-          <a:fontRef idx="minor">
-            <a:schemeClr val="lt1"/>
-          </a:fontRef>
-        </p:style>
-        <p:txBody>
-          <a:bodyPr rtlCol="0" anchor="ctr"/>
-          <a:lstStyle/>
-          <a:p>
-            <a:pPr algn="ctr"/>
-            <a:r>
-              <a:rPr lang="es-MX" sz="1200" dirty="0">
-                <a:solidFill>
-                  <a:schemeClr val="tx1"/>
-                </a:solidFill>
-                <a:latin typeface="Arial" panose="020B0604020202020204" pitchFamily="34" charset="0"/>
-                <a:cs typeface="Arial" panose="020B0604020202020204" pitchFamily="34" charset="0"/>
-              </a:rPr>
-              <a:t>Recuperar contraseña</a:t>
-            </a:r>
-            <a:endParaRPr lang="es-CO" sz="1200" dirty="0">
-              <a:solidFill>
-                <a:schemeClr val="tx1"/>
-              </a:solidFill>
-              <a:latin typeface="Arial" panose="020B0604020202020204" pitchFamily="34" charset="0"/>
-              <a:cs typeface="Arial" panose="020B0604020202020204" pitchFamily="34" charset="0"/>
-            </a:endParaRPr>
+              <a:t>Acceso</a:t>
+            </a:r>
           </a:p>
         </p:txBody>
       </p:sp>
       <p:cxnSp>
         <p:nvCxnSpPr>
-          <p:cNvPr id="37" name="Conector: angular 36">
-            <a:extLst>
-              <a:ext uri="{FF2B5EF4-FFF2-40B4-BE49-F238E27FC236}">
-                <a16:creationId xmlns:a16="http://schemas.microsoft.com/office/drawing/2014/main" id="{FF539C90-7F14-F707-7B20-309E08649AB6}"/>
-              </a:ext>
-            </a:extLst>
-          </p:cNvPr>
-          <p:cNvCxnSpPr>
-            <a:cxnSpLocks/>
-            <a:stCxn id="20" idx="2"/>
-            <a:endCxn id="27" idx="0"/>
-          </p:cNvCxnSpPr>
+          <p:cNvPr id="4" name="Connector 3"/>
+          <p:cNvCxnSpPr/>
           <p:nvPr/>
         </p:nvCxnSpPr>
         <p:spPr>
-          <a:xfrm rot="5400000">
-            <a:off x="-73854" y="3263549"/>
-            <a:ext cx="2647949" cy="534588"/>
-          </a:xfrm>
-          <a:prstGeom prst="bentConnector3">
-            <a:avLst>
-              <a:gd name="adj1" fmla="val 76121"/>
-            </a:avLst>
-          </a:prstGeom>
-          <a:ln>
-            <a:headEnd type="triangle"/>
-            <a:tailEnd type="triangle"/>
+          <a:xfrm>
+            <a:off x="1028700" y="704088"/>
+            <a:ext cx="0" cy="192024"/>
+          </a:xfrm>
+          <a:prstGeom prst="line">
+            <a:avLst/>
+          </a:prstGeom>
+          <a:ln w="9525">
+            <a:solidFill>
+              <a:srgbClr val="BDD7EE"/>
+            </a:solidFill>
+            <a:tailEnd type="triangle" w="sm" len="sm"/>
           </a:ln>
         </p:spPr>
         <p:style>
@@ -3999,35 +3506,81 @@
           </a:fontRef>
         </p:style>
       </p:cxnSp>
+      <p:sp>
+        <p:nvSpPr>
+          <p:cNvPr id="5" name="Rounded Rectangle 4"/>
+          <p:cNvSpPr/>
+          <p:nvPr/>
+        </p:nvSpPr>
+        <p:spPr>
+          <a:xfrm>
+            <a:off x="228600" y="1536192"/>
+            <a:ext cx="1600200" cy="365760"/>
+          </a:xfrm>
+          <a:prstGeom prst="roundRect">
+            <a:avLst>
+              <a:gd name="adj" fmla="val 14000"/>
+            </a:avLst>
+          </a:prstGeom>
+          <a:solidFill>
+            <a:srgbClr val="FFFFFF"/>
+          </a:solidFill>
+          <a:ln w="12700">
+            <a:solidFill>
+              <a:srgbClr val="8FAADC"/>
+            </a:solidFill>
+          </a:ln>
+          <a:effectLst/>
+        </p:spPr>
+        <p:style>
+          <a:lnRef idx="1">
+            <a:schemeClr val="accent1"/>
+          </a:lnRef>
+          <a:fillRef idx="3">
+            <a:schemeClr val="accent1"/>
+          </a:fillRef>
+          <a:effectRef idx="2">
+            <a:schemeClr val="accent1"/>
+          </a:effectRef>
+          <a:fontRef idx="minor">
+            <a:schemeClr val="lt1"/>
+          </a:fontRef>
+        </p:style>
+        <p:txBody>
+          <a:bodyPr rtlCol="0" anchor="ctr" wrap="square" lIns="25400" rIns="25400" tIns="0" bIns="0"/>
+          <a:lstStyle/>
+          <a:p>
+            <a:pPr algn="ctr"/>
+            <a:r>
+              <a:rPr sz="950" b="0">
+                <a:solidFill>
+                  <a:srgbClr val="1F3864"/>
+                </a:solidFill>
+              </a:rPr>
+              <a:t>Iniciar sesión</a:t>
+            </a:r>
+          </a:p>
+        </p:txBody>
+      </p:sp>
       <p:cxnSp>
         <p:nvCxnSpPr>
-          <p:cNvPr id="41" name="Conector: angular 40">
-            <a:extLst>
-              <a:ext uri="{FF2B5EF4-FFF2-40B4-BE49-F238E27FC236}">
-                <a16:creationId xmlns:a16="http://schemas.microsoft.com/office/drawing/2014/main" id="{2EDD759E-333F-30BC-DE28-2F968F3DCEB0}"/>
-              </a:ext>
-            </a:extLst>
-          </p:cNvPr>
-          <p:cNvCxnSpPr>
-            <a:cxnSpLocks/>
-            <a:stCxn id="20" idx="2"/>
-            <a:endCxn id="28" idx="0"/>
-          </p:cNvCxnSpPr>
+          <p:cNvPr id="6" name="Connector 5"/>
+          <p:cNvCxnSpPr/>
           <p:nvPr/>
         </p:nvCxnSpPr>
         <p:spPr>
-          <a:xfrm rot="16200000" flipH="1">
-            <a:off x="812981" y="2911301"/>
-            <a:ext cx="2647951" cy="1239085"/>
-          </a:xfrm>
-          <a:prstGeom prst="bentConnector3">
-            <a:avLst>
-              <a:gd name="adj1" fmla="val 76121"/>
-            </a:avLst>
-          </a:prstGeom>
-          <a:ln>
-            <a:headEnd type="triangle"/>
-            <a:tailEnd type="triangle"/>
+          <a:xfrm>
+            <a:off x="1028700" y="1353312"/>
+            <a:ext cx="0" cy="182880"/>
+          </a:xfrm>
+          <a:prstGeom prst="line">
+            <a:avLst/>
+          </a:prstGeom>
+          <a:ln w="9525">
+            <a:solidFill>
+              <a:srgbClr val="8FAADC"/>
+            </a:solidFill>
+            <a:tailEnd type="triangle" w="sm" len="sm"/>
           </a:ln>
         </p:spPr>
         <p:style>
@@ -4045,35 +3598,81 @@
           </a:fontRef>
         </p:style>
       </p:cxnSp>
+      <p:sp>
+        <p:nvSpPr>
+          <p:cNvPr id="7" name="Rounded Rectangle 6"/>
+          <p:cNvSpPr/>
+          <p:nvPr/>
+        </p:nvSpPr>
+        <p:spPr>
+          <a:xfrm>
+            <a:off x="228600" y="1993391"/>
+            <a:ext cx="1600200" cy="365760"/>
+          </a:xfrm>
+          <a:prstGeom prst="roundRect">
+            <a:avLst>
+              <a:gd name="adj" fmla="val 14000"/>
+            </a:avLst>
+          </a:prstGeom>
+          <a:solidFill>
+            <a:srgbClr val="FFFFFF"/>
+          </a:solidFill>
+          <a:ln w="12700">
+            <a:solidFill>
+              <a:srgbClr val="8FAADC"/>
+            </a:solidFill>
+          </a:ln>
+          <a:effectLst/>
+        </p:spPr>
+        <p:style>
+          <a:lnRef idx="1">
+            <a:schemeClr val="accent1"/>
+          </a:lnRef>
+          <a:fillRef idx="3">
+            <a:schemeClr val="accent1"/>
+          </a:fillRef>
+          <a:effectRef idx="2">
+            <a:schemeClr val="accent1"/>
+          </a:effectRef>
+          <a:fontRef idx="minor">
+            <a:schemeClr val="lt1"/>
+          </a:fontRef>
+        </p:style>
+        <p:txBody>
+          <a:bodyPr rtlCol="0" anchor="ctr" wrap="square" lIns="25400" rIns="25400" tIns="0" bIns="0"/>
+          <a:lstStyle/>
+          <a:p>
+            <a:pPr algn="ctr"/>
+            <a:r>
+              <a:rPr sz="950" b="0">
+                <a:solidFill>
+                  <a:srgbClr val="1F3864"/>
+                </a:solidFill>
+              </a:rPr>
+              <a:t>Registrarse</a:t>
+            </a:r>
+          </a:p>
+        </p:txBody>
+      </p:sp>
       <p:cxnSp>
         <p:nvCxnSpPr>
-          <p:cNvPr id="55" name="Conector: angular 54">
-            <a:extLst>
-              <a:ext uri="{FF2B5EF4-FFF2-40B4-BE49-F238E27FC236}">
-                <a16:creationId xmlns:a16="http://schemas.microsoft.com/office/drawing/2014/main" id="{550F2400-BC90-8970-734A-C21E4D541628}"/>
-              </a:ext>
-            </a:extLst>
-          </p:cNvPr>
-          <p:cNvCxnSpPr>
-            <a:cxnSpLocks/>
-            <a:stCxn id="20" idx="2"/>
-            <a:endCxn id="31" idx="0"/>
-          </p:cNvCxnSpPr>
+          <p:cNvPr id="8" name="Connector 7"/>
+          <p:cNvCxnSpPr/>
           <p:nvPr/>
         </p:nvCxnSpPr>
         <p:spPr>
-          <a:xfrm rot="16200000" flipH="1">
-            <a:off x="1847960" y="1876323"/>
-            <a:ext cx="2658208" cy="3319300"/>
-          </a:xfrm>
-          <a:prstGeom prst="bentConnector3">
-            <a:avLst>
-              <a:gd name="adj1" fmla="val 75579"/>
-            </a:avLst>
-          </a:prstGeom>
-          <a:ln>
-            <a:headEnd type="triangle"/>
-            <a:tailEnd type="triangle"/>
+          <a:xfrm>
+            <a:off x="1028700" y="1353312"/>
+            <a:ext cx="0" cy="640079"/>
+          </a:xfrm>
+          <a:prstGeom prst="line">
+            <a:avLst/>
+          </a:prstGeom>
+          <a:ln w="9525">
+            <a:solidFill>
+              <a:srgbClr val="8FAADC"/>
+            </a:solidFill>
+            <a:tailEnd type="triangle" w="sm" len="sm"/>
           </a:ln>
         </p:spPr>
         <p:style>
@@ -4093,43 +3692,38 @@
       </p:cxnSp>
       <p:sp>
         <p:nvSpPr>
-          <p:cNvPr id="70" name="Rectángulo 69">
-            <a:extLst>
-              <a:ext uri="{FF2B5EF4-FFF2-40B4-BE49-F238E27FC236}">
-                <a16:creationId xmlns:a16="http://schemas.microsoft.com/office/drawing/2014/main" id="{E0F7437E-C9C3-AE7D-9FF1-F939EC3B2599}"/>
-              </a:ext>
-            </a:extLst>
-          </p:cNvPr>
+          <p:cNvPr id="9" name="Rounded Rectangle 8"/>
           <p:cNvSpPr/>
           <p:nvPr/>
         </p:nvSpPr>
         <p:spPr>
           <a:xfrm>
-            <a:off x="8081337" y="2680559"/>
-            <a:ext cx="1233855" cy="366346"/>
-          </a:xfrm>
-          <a:prstGeom prst="rect">
-            <a:avLst/>
+            <a:off x="228600" y="2450591"/>
+            <a:ext cx="1600200" cy="365760"/>
+          </a:xfrm>
+          <a:prstGeom prst="roundRect">
+            <a:avLst>
+              <a:gd name="adj" fmla="val 14000"/>
+            </a:avLst>
           </a:prstGeom>
           <a:solidFill>
-            <a:schemeClr val="bg1"/>
+            <a:srgbClr val="FFFFFF"/>
           </a:solidFill>
-          <a:ln>
+          <a:ln w="12700">
             <a:solidFill>
-              <a:srgbClr val="FF0000"/>
+              <a:srgbClr val="8FAADC"/>
             </a:solidFill>
           </a:ln>
+          <a:effectLst/>
         </p:spPr>
         <p:style>
-          <a:lnRef idx="2">
-            <a:schemeClr val="accent1">
-              <a:shade val="15000"/>
-            </a:schemeClr>
+          <a:lnRef idx="1">
+            <a:schemeClr val="accent1"/>
           </a:lnRef>
-          <a:fillRef idx="1">
+          <a:fillRef idx="3">
             <a:schemeClr val="accent1"/>
           </a:fillRef>
-          <a:effectRef idx="0">
+          <a:effectRef idx="2">
             <a:schemeClr val="accent1"/>
           </a:effectRef>
           <a:fontRef idx="minor">
@@ -4137,199 +3731,40 @@
           </a:fontRef>
         </p:style>
         <p:txBody>
-          <a:bodyPr rtlCol="0" anchor="ctr"/>
+          <a:bodyPr rtlCol="0" anchor="ctr" wrap="square" lIns="25400" rIns="25400" tIns="0" bIns="0"/>
           <a:lstStyle/>
           <a:p>
             <a:pPr algn="ctr"/>
             <a:r>
-              <a:rPr lang="es-MX" sz="1200" dirty="0">
+              <a:rPr sz="950" b="0">
                 <a:solidFill>
-                  <a:schemeClr val="tx1"/>
+                  <a:srgbClr val="1F3864"/>
                 </a:solidFill>
-                <a:latin typeface="Arial" panose="020B0604020202020204" pitchFamily="34" charset="0"/>
-                <a:cs typeface="Arial" panose="020B0604020202020204" pitchFamily="34" charset="0"/>
               </a:rPr>
-              <a:t>Crear Proyecto</a:t>
-            </a:r>
-            <a:endParaRPr lang="es-CO" sz="1200" dirty="0">
-              <a:solidFill>
-                <a:schemeClr val="tx1"/>
-              </a:solidFill>
-              <a:latin typeface="Arial" panose="020B0604020202020204" pitchFamily="34" charset="0"/>
-              <a:cs typeface="Arial" panose="020B0604020202020204" pitchFamily="34" charset="0"/>
-            </a:endParaRPr>
-          </a:p>
-        </p:txBody>
-      </p:sp>
-      <p:sp>
-        <p:nvSpPr>
-          <p:cNvPr id="71" name="Rectángulo 70">
-            <a:extLst>
-              <a:ext uri="{FF2B5EF4-FFF2-40B4-BE49-F238E27FC236}">
-                <a16:creationId xmlns:a16="http://schemas.microsoft.com/office/drawing/2014/main" id="{C3557981-5800-D012-8352-0A5B919B9C2E}"/>
-              </a:ext>
-            </a:extLst>
-          </p:cNvPr>
-          <p:cNvSpPr/>
-          <p:nvPr/>
-        </p:nvSpPr>
-        <p:spPr>
-          <a:xfrm>
-            <a:off x="8008247" y="3429000"/>
-            <a:ext cx="1380033" cy="366346"/>
-          </a:xfrm>
-          <a:prstGeom prst="rect">
-            <a:avLst/>
-          </a:prstGeom>
-          <a:solidFill>
-            <a:schemeClr val="bg1"/>
-          </a:solidFill>
-          <a:ln>
-            <a:solidFill>
-              <a:srgbClr val="FF0000"/>
-            </a:solidFill>
-          </a:ln>
-        </p:spPr>
-        <p:style>
-          <a:lnRef idx="2">
-            <a:schemeClr val="accent1">
-              <a:shade val="15000"/>
-            </a:schemeClr>
-          </a:lnRef>
-          <a:fillRef idx="1">
-            <a:schemeClr val="accent1"/>
-          </a:fillRef>
-          <a:effectRef idx="0">
-            <a:schemeClr val="accent1"/>
-          </a:effectRef>
-          <a:fontRef idx="minor">
-            <a:schemeClr val="lt1"/>
-          </a:fontRef>
-        </p:style>
-        <p:txBody>
-          <a:bodyPr rtlCol="0" anchor="ctr"/>
-          <a:lstStyle/>
-          <a:p>
-            <a:pPr algn="ctr"/>
-            <a:r>
-              <a:rPr lang="es-MX" sz="1200" dirty="0">
-                <a:solidFill>
-                  <a:schemeClr val="tx1"/>
-                </a:solidFill>
-                <a:latin typeface="Arial" panose="020B0604020202020204" pitchFamily="34" charset="0"/>
-                <a:cs typeface="Arial" panose="020B0604020202020204" pitchFamily="34" charset="0"/>
-              </a:rPr>
-              <a:t>Asociar usuarios</a:t>
-            </a:r>
-            <a:endParaRPr lang="es-CO" sz="1200" dirty="0">
-              <a:solidFill>
-                <a:schemeClr val="tx1"/>
-              </a:solidFill>
-              <a:latin typeface="Arial" panose="020B0604020202020204" pitchFamily="34" charset="0"/>
-              <a:cs typeface="Arial" panose="020B0604020202020204" pitchFamily="34" charset="0"/>
-            </a:endParaRPr>
-          </a:p>
-        </p:txBody>
-      </p:sp>
-      <p:sp>
-        <p:nvSpPr>
-          <p:cNvPr id="72" name="Rectángulo 71">
-            <a:extLst>
-              <a:ext uri="{FF2B5EF4-FFF2-40B4-BE49-F238E27FC236}">
-                <a16:creationId xmlns:a16="http://schemas.microsoft.com/office/drawing/2014/main" id="{5F6D52FE-9C64-AE4D-37B4-0F02BFB77F7D}"/>
-              </a:ext>
-            </a:extLst>
-          </p:cNvPr>
-          <p:cNvSpPr/>
-          <p:nvPr/>
-        </p:nvSpPr>
-        <p:spPr>
-          <a:xfrm>
-            <a:off x="7870322" y="4144854"/>
-            <a:ext cx="1655881" cy="366346"/>
-          </a:xfrm>
-          <a:prstGeom prst="rect">
-            <a:avLst/>
-          </a:prstGeom>
-          <a:solidFill>
-            <a:schemeClr val="bg1"/>
-          </a:solidFill>
-          <a:ln>
-            <a:solidFill>
-              <a:srgbClr val="FF0000"/>
-            </a:solidFill>
-          </a:ln>
-        </p:spPr>
-        <p:style>
-          <a:lnRef idx="2">
-            <a:schemeClr val="accent1">
-              <a:shade val="15000"/>
-            </a:schemeClr>
-          </a:lnRef>
-          <a:fillRef idx="1">
-            <a:schemeClr val="accent1"/>
-          </a:fillRef>
-          <a:effectRef idx="0">
-            <a:schemeClr val="accent1"/>
-          </a:effectRef>
-          <a:fontRef idx="minor">
-            <a:schemeClr val="lt1"/>
-          </a:fontRef>
-        </p:style>
-        <p:txBody>
-          <a:bodyPr rtlCol="0" anchor="ctr"/>
-          <a:lstStyle/>
-          <a:p>
-            <a:pPr algn="ctr"/>
-            <a:r>
-              <a:rPr lang="es-MX" sz="1200" dirty="0">
-                <a:solidFill>
-                  <a:schemeClr val="tx1"/>
-                </a:solidFill>
-                <a:latin typeface="Arial" panose="020B0604020202020204" pitchFamily="34" charset="0"/>
-                <a:cs typeface="Arial" panose="020B0604020202020204" pitchFamily="34" charset="0"/>
-              </a:rPr>
-              <a:t>Vincular dispositivos</a:t>
-            </a:r>
-            <a:endParaRPr lang="es-CO" sz="1200" dirty="0">
-              <a:solidFill>
-                <a:schemeClr val="tx1"/>
-              </a:solidFill>
-              <a:latin typeface="Arial" panose="020B0604020202020204" pitchFamily="34" charset="0"/>
-              <a:cs typeface="Arial" panose="020B0604020202020204" pitchFamily="34" charset="0"/>
-            </a:endParaRPr>
+              <a:t>Recuperar contraseña</a:t>
+            </a:r>
           </a:p>
         </p:txBody>
       </p:sp>
       <p:cxnSp>
         <p:nvCxnSpPr>
-          <p:cNvPr id="74" name="Conector: angular 73">
-            <a:extLst>
-              <a:ext uri="{FF2B5EF4-FFF2-40B4-BE49-F238E27FC236}">
-                <a16:creationId xmlns:a16="http://schemas.microsoft.com/office/drawing/2014/main" id="{2CC460E6-EE9B-371A-AD17-373389B61CDF}"/>
-              </a:ext>
-            </a:extLst>
-          </p:cNvPr>
-          <p:cNvCxnSpPr>
-            <a:cxnSpLocks/>
-            <a:stCxn id="15" idx="2"/>
-            <a:endCxn id="70" idx="0"/>
-          </p:cNvCxnSpPr>
+          <p:cNvPr id="10" name="Connector 9"/>
+          <p:cNvCxnSpPr/>
           <p:nvPr/>
         </p:nvCxnSpPr>
         <p:spPr>
-          <a:xfrm rot="5400000">
-            <a:off x="8461761" y="2443372"/>
-            <a:ext cx="473692" cy="683"/>
-          </a:xfrm>
-          <a:prstGeom prst="bentConnector3">
-            <a:avLst>
-              <a:gd name="adj1" fmla="val 50000"/>
-            </a:avLst>
-          </a:prstGeom>
-          <a:ln>
-            <a:headEnd type="triangle"/>
-            <a:tailEnd type="triangle"/>
+          <a:xfrm>
+            <a:off x="1028700" y="1353312"/>
+            <a:ext cx="0" cy="1097279"/>
+          </a:xfrm>
+          <a:prstGeom prst="line">
+            <a:avLst/>
+          </a:prstGeom>
+          <a:ln w="9525">
+            <a:solidFill>
+              <a:srgbClr val="8FAADC"/>
+            </a:solidFill>
+            <a:tailEnd type="triangle" w="sm" len="sm"/>
           </a:ln>
         </p:spPr>
         <p:style>
@@ -4347,33 +3782,81 @@
           </a:fontRef>
         </p:style>
       </p:cxnSp>
+      <p:sp>
+        <p:nvSpPr>
+          <p:cNvPr id="11" name="Rounded Rectangle 10"/>
+          <p:cNvSpPr/>
+          <p:nvPr/>
+        </p:nvSpPr>
+        <p:spPr>
+          <a:xfrm>
+            <a:off x="228600" y="2907791"/>
+            <a:ext cx="1600200" cy="365760"/>
+          </a:xfrm>
+          <a:prstGeom prst="roundRect">
+            <a:avLst>
+              <a:gd name="adj" fmla="val 14000"/>
+            </a:avLst>
+          </a:prstGeom>
+          <a:solidFill>
+            <a:srgbClr val="FFFFFF"/>
+          </a:solidFill>
+          <a:ln w="12700">
+            <a:solidFill>
+              <a:srgbClr val="8FAADC"/>
+            </a:solidFill>
+          </a:ln>
+          <a:effectLst/>
+        </p:spPr>
+        <p:style>
+          <a:lnRef idx="1">
+            <a:schemeClr val="accent1"/>
+          </a:lnRef>
+          <a:fillRef idx="3">
+            <a:schemeClr val="accent1"/>
+          </a:fillRef>
+          <a:effectRef idx="2">
+            <a:schemeClr val="accent1"/>
+          </a:effectRef>
+          <a:fontRef idx="minor">
+            <a:schemeClr val="lt1"/>
+          </a:fontRef>
+        </p:style>
+        <p:txBody>
+          <a:bodyPr rtlCol="0" anchor="ctr" wrap="square" lIns="25400" rIns="25400" tIns="0" bIns="0"/>
+          <a:lstStyle/>
+          <a:p>
+            <a:pPr algn="ctr"/>
+            <a:r>
+              <a:rPr sz="950" b="0">
+                <a:solidFill>
+                  <a:srgbClr val="1F3864"/>
+                </a:solidFill>
+              </a:rPr>
+              <a:t>Verificar cuenta</a:t>
+            </a:r>
+          </a:p>
+        </p:txBody>
+      </p:sp>
       <p:cxnSp>
         <p:nvCxnSpPr>
-          <p:cNvPr id="79" name="Conector recto de flecha 78">
-            <a:extLst>
-              <a:ext uri="{FF2B5EF4-FFF2-40B4-BE49-F238E27FC236}">
-                <a16:creationId xmlns:a16="http://schemas.microsoft.com/office/drawing/2014/main" id="{EFB2C2B1-BC3E-550D-9F5B-8FBF9B699A37}"/>
-              </a:ext>
-            </a:extLst>
-          </p:cNvPr>
-          <p:cNvCxnSpPr>
-            <a:cxnSpLocks/>
-            <a:stCxn id="70" idx="2"/>
-            <a:endCxn id="71" idx="0"/>
-          </p:cNvCxnSpPr>
+          <p:cNvPr id="12" name="Connector 11"/>
+          <p:cNvCxnSpPr/>
           <p:nvPr/>
         </p:nvCxnSpPr>
         <p:spPr>
-          <a:xfrm flipH="1">
-            <a:off x="8698264" y="3046905"/>
-            <a:ext cx="1" cy="382095"/>
-          </a:xfrm>
-          <a:prstGeom prst="straightConnector1">
+          <a:xfrm>
+            <a:off x="1028700" y="1353312"/>
+            <a:ext cx="0" cy="1554479"/>
+          </a:xfrm>
+          <a:prstGeom prst="line">
             <a:avLst/>
           </a:prstGeom>
-          <a:ln>
-            <a:headEnd type="triangle"/>
-            <a:tailEnd type="triangle"/>
+          <a:ln w="9525">
+            <a:solidFill>
+              <a:srgbClr val="8FAADC"/>
+            </a:solidFill>
+            <a:tailEnd type="triangle" w="sm" len="sm"/>
           </a:ln>
         </p:spPr>
         <p:style>
@@ -4391,33 +3874,81 @@
           </a:fontRef>
         </p:style>
       </p:cxnSp>
+      <p:sp>
+        <p:nvSpPr>
+          <p:cNvPr id="13" name="Rounded Rectangle 12"/>
+          <p:cNvSpPr/>
+          <p:nvPr/>
+        </p:nvSpPr>
+        <p:spPr>
+          <a:xfrm>
+            <a:off x="1938528" y="896112"/>
+            <a:ext cx="1600200" cy="457200"/>
+          </a:xfrm>
+          <a:prstGeom prst="roundRect">
+            <a:avLst>
+              <a:gd name="adj" fmla="val 14000"/>
+            </a:avLst>
+          </a:prstGeom>
+          <a:solidFill>
+            <a:srgbClr val="1F4E79"/>
+          </a:solidFill>
+          <a:ln w="12700">
+            <a:solidFill>
+              <a:srgbClr val="1F4E79"/>
+            </a:solidFill>
+          </a:ln>
+          <a:effectLst/>
+        </p:spPr>
+        <p:style>
+          <a:lnRef idx="1">
+            <a:schemeClr val="accent1"/>
+          </a:lnRef>
+          <a:fillRef idx="3">
+            <a:schemeClr val="accent1"/>
+          </a:fillRef>
+          <a:effectRef idx="2">
+            <a:schemeClr val="accent1"/>
+          </a:effectRef>
+          <a:fontRef idx="minor">
+            <a:schemeClr val="lt1"/>
+          </a:fontRef>
+        </p:style>
+        <p:txBody>
+          <a:bodyPr rtlCol="0" anchor="ctr" wrap="square" lIns="25400" rIns="25400" tIns="0" bIns="0"/>
+          <a:lstStyle/>
+          <a:p>
+            <a:pPr algn="ctr"/>
+            <a:r>
+              <a:rPr sz="1100" b="1">
+                <a:solidFill>
+                  <a:srgbClr val="FFFFFF"/>
+                </a:solidFill>
+              </a:rPr>
+              <a:t>Inicio</a:t>
+            </a:r>
+          </a:p>
+        </p:txBody>
+      </p:sp>
       <p:cxnSp>
         <p:nvCxnSpPr>
-          <p:cNvPr id="83" name="Conector recto de flecha 82">
-            <a:extLst>
-              <a:ext uri="{FF2B5EF4-FFF2-40B4-BE49-F238E27FC236}">
-                <a16:creationId xmlns:a16="http://schemas.microsoft.com/office/drawing/2014/main" id="{C34EAA2E-817E-B484-C1D4-8D1438D4CEFC}"/>
-              </a:ext>
-            </a:extLst>
-          </p:cNvPr>
-          <p:cNvCxnSpPr>
-            <a:cxnSpLocks/>
-            <a:stCxn id="71" idx="2"/>
-            <a:endCxn id="72" idx="0"/>
-          </p:cNvCxnSpPr>
+          <p:cNvPr id="14" name="Connector 13"/>
+          <p:cNvCxnSpPr/>
           <p:nvPr/>
         </p:nvCxnSpPr>
         <p:spPr>
-          <a:xfrm flipH="1">
-            <a:off x="8698263" y="3795346"/>
-            <a:ext cx="1" cy="349508"/>
-          </a:xfrm>
-          <a:prstGeom prst="straightConnector1">
+          <a:xfrm>
+            <a:off x="2738628" y="704088"/>
+            <a:ext cx="0" cy="192024"/>
+          </a:xfrm>
+          <a:prstGeom prst="line">
             <a:avLst/>
           </a:prstGeom>
-          <a:ln>
-            <a:headEnd type="triangle"/>
-            <a:tailEnd type="triangle"/>
+          <a:ln w="9525">
+            <a:solidFill>
+              <a:srgbClr val="BDD7EE"/>
+            </a:solidFill>
+            <a:tailEnd type="triangle" w="sm" len="sm"/>
           </a:ln>
         </p:spPr>
         <p:style>
@@ -4437,43 +3968,38 @@
       </p:cxnSp>
       <p:sp>
         <p:nvSpPr>
-          <p:cNvPr id="84" name="Rectángulo 83">
-            <a:extLst>
-              <a:ext uri="{FF2B5EF4-FFF2-40B4-BE49-F238E27FC236}">
-                <a16:creationId xmlns:a16="http://schemas.microsoft.com/office/drawing/2014/main" id="{49E96B3B-8044-F95C-AB6A-59D086AF8392}"/>
-              </a:ext>
-            </a:extLst>
-          </p:cNvPr>
+          <p:cNvPr id="15" name="Rounded Rectangle 14"/>
           <p:cNvSpPr/>
           <p:nvPr/>
         </p:nvSpPr>
         <p:spPr>
           <a:xfrm>
-            <a:off x="2631504" y="2485392"/>
-            <a:ext cx="1678563" cy="366346"/>
-          </a:xfrm>
-          <a:prstGeom prst="rect">
-            <a:avLst/>
+            <a:off x="1938528" y="1536192"/>
+            <a:ext cx="1600200" cy="365760"/>
+          </a:xfrm>
+          <a:prstGeom prst="roundRect">
+            <a:avLst>
+              <a:gd name="adj" fmla="val 14000"/>
+            </a:avLst>
           </a:prstGeom>
           <a:solidFill>
-            <a:schemeClr val="bg1"/>
+            <a:srgbClr val="FFFFFF"/>
           </a:solidFill>
-          <a:ln>
+          <a:ln w="12700">
             <a:solidFill>
-              <a:srgbClr val="FF0000"/>
+              <a:srgbClr val="8FAADC"/>
             </a:solidFill>
           </a:ln>
+          <a:effectLst/>
         </p:spPr>
         <p:style>
-          <a:lnRef idx="2">
-            <a:schemeClr val="accent1">
-              <a:shade val="15000"/>
-            </a:schemeClr>
+          <a:lnRef idx="1">
+            <a:schemeClr val="accent1"/>
           </a:lnRef>
-          <a:fillRef idx="1">
+          <a:fillRef idx="3">
             <a:schemeClr val="accent1"/>
           </a:fillRef>
-          <a:effectRef idx="0">
+          <a:effectRef idx="2">
             <a:schemeClr val="accent1"/>
           </a:effectRef>
           <a:fontRef idx="minor">
@@ -4481,457 +4007,40 @@
           </a:fontRef>
         </p:style>
         <p:txBody>
-          <a:bodyPr rtlCol="0" anchor="ctr"/>
+          <a:bodyPr rtlCol="0" anchor="ctr" wrap="square" lIns="25400" rIns="25400" tIns="0" bIns="0"/>
           <a:lstStyle/>
           <a:p>
             <a:pPr algn="ctr"/>
             <a:r>
-              <a:rPr lang="es-MX" sz="1200" dirty="0">
+              <a:rPr sz="950" b="0">
                 <a:solidFill>
-                  <a:schemeClr val="tx1"/>
+                  <a:srgbClr val="1F3864"/>
                 </a:solidFill>
-                <a:latin typeface="Arial" panose="020B0604020202020204" pitchFamily="34" charset="0"/>
-                <a:cs typeface="Arial" panose="020B0604020202020204" pitchFamily="34" charset="0"/>
               </a:rPr>
-              <a:t>Seleccionar proyecto</a:t>
-            </a:r>
-            <a:endParaRPr lang="es-CO" sz="1200" dirty="0">
-              <a:solidFill>
-                <a:schemeClr val="tx1"/>
-              </a:solidFill>
-              <a:latin typeface="Arial" panose="020B0604020202020204" pitchFamily="34" charset="0"/>
-              <a:cs typeface="Arial" panose="020B0604020202020204" pitchFamily="34" charset="0"/>
-            </a:endParaRPr>
-          </a:p>
-        </p:txBody>
-      </p:sp>
-      <p:sp>
-        <p:nvSpPr>
-          <p:cNvPr id="96" name="Rectángulo 95">
-            <a:extLst>
-              <a:ext uri="{FF2B5EF4-FFF2-40B4-BE49-F238E27FC236}">
-                <a16:creationId xmlns:a16="http://schemas.microsoft.com/office/drawing/2014/main" id="{B7C2AB45-726E-7637-1632-1A74B8E7E76C}"/>
-              </a:ext>
-            </a:extLst>
-          </p:cNvPr>
-          <p:cNvSpPr/>
-          <p:nvPr/>
-        </p:nvSpPr>
-        <p:spPr>
-          <a:xfrm>
-            <a:off x="2432387" y="3102642"/>
-            <a:ext cx="2076798" cy="366346"/>
-          </a:xfrm>
-          <a:prstGeom prst="rect">
-            <a:avLst/>
-          </a:prstGeom>
-          <a:solidFill>
-            <a:schemeClr val="bg1"/>
-          </a:solidFill>
-          <a:ln>
-            <a:solidFill>
-              <a:srgbClr val="FF0000"/>
-            </a:solidFill>
-          </a:ln>
-        </p:spPr>
-        <p:style>
-          <a:lnRef idx="2">
-            <a:schemeClr val="accent1">
-              <a:shade val="15000"/>
-            </a:schemeClr>
-          </a:lnRef>
-          <a:fillRef idx="1">
-            <a:schemeClr val="accent1"/>
-          </a:fillRef>
-          <a:effectRef idx="0">
-            <a:schemeClr val="accent1"/>
-          </a:effectRef>
-          <a:fontRef idx="minor">
-            <a:schemeClr val="lt1"/>
-          </a:fontRef>
-        </p:style>
-        <p:txBody>
-          <a:bodyPr rtlCol="0" anchor="ctr"/>
-          <a:lstStyle/>
-          <a:p>
-            <a:pPr algn="ctr"/>
-            <a:r>
-              <a:rPr lang="es-MX" sz="1200" dirty="0">
-                <a:solidFill>
-                  <a:schemeClr val="tx1"/>
-                </a:solidFill>
-                <a:latin typeface="Arial" panose="020B0604020202020204" pitchFamily="34" charset="0"/>
-                <a:cs typeface="Arial" panose="020B0604020202020204" pitchFamily="34" charset="0"/>
-              </a:rPr>
-              <a:t>Seleccionar Dispositivo</a:t>
-            </a:r>
-            <a:endParaRPr lang="es-CO" sz="1200" dirty="0">
-              <a:solidFill>
-                <a:schemeClr val="tx1"/>
-              </a:solidFill>
-              <a:latin typeface="Arial" panose="020B0604020202020204" pitchFamily="34" charset="0"/>
-              <a:cs typeface="Arial" panose="020B0604020202020204" pitchFamily="34" charset="0"/>
-            </a:endParaRPr>
-          </a:p>
-        </p:txBody>
-      </p:sp>
-      <p:sp>
-        <p:nvSpPr>
-          <p:cNvPr id="97" name="Rectángulo 96">
-            <a:extLst>
-              <a:ext uri="{FF2B5EF4-FFF2-40B4-BE49-F238E27FC236}">
-                <a16:creationId xmlns:a16="http://schemas.microsoft.com/office/drawing/2014/main" id="{30746ABD-222A-ED00-7A05-14555FB6F3D4}"/>
-              </a:ext>
-            </a:extLst>
-          </p:cNvPr>
-          <p:cNvSpPr/>
-          <p:nvPr/>
-        </p:nvSpPr>
-        <p:spPr>
-          <a:xfrm>
-            <a:off x="2610414" y="3719892"/>
-            <a:ext cx="1711185" cy="366346"/>
-          </a:xfrm>
-          <a:prstGeom prst="rect">
-            <a:avLst/>
-          </a:prstGeom>
-          <a:solidFill>
-            <a:schemeClr val="bg1"/>
-          </a:solidFill>
-          <a:ln>
-            <a:solidFill>
-              <a:srgbClr val="FF0000"/>
-            </a:solidFill>
-          </a:ln>
-        </p:spPr>
-        <p:style>
-          <a:lnRef idx="2">
-            <a:schemeClr val="accent1">
-              <a:shade val="15000"/>
-            </a:schemeClr>
-          </a:lnRef>
-          <a:fillRef idx="1">
-            <a:schemeClr val="accent1"/>
-          </a:fillRef>
-          <a:effectRef idx="0">
-            <a:schemeClr val="accent1"/>
-          </a:effectRef>
-          <a:fontRef idx="minor">
-            <a:schemeClr val="lt1"/>
-          </a:fontRef>
-        </p:style>
-        <p:txBody>
-          <a:bodyPr rtlCol="0" anchor="ctr"/>
-          <a:lstStyle/>
-          <a:p>
-            <a:pPr algn="ctr"/>
-            <a:r>
-              <a:rPr lang="es-MX" sz="1200" dirty="0">
-                <a:solidFill>
-                  <a:schemeClr val="tx1"/>
-                </a:solidFill>
-                <a:latin typeface="Arial" panose="020B0604020202020204" pitchFamily="34" charset="0"/>
-                <a:cs typeface="Arial" panose="020B0604020202020204" pitchFamily="34" charset="0"/>
-              </a:rPr>
-              <a:t>Visualizar consumo</a:t>
-            </a:r>
-            <a:endParaRPr lang="es-CO" sz="1200" dirty="0">
-              <a:solidFill>
-                <a:schemeClr val="tx1"/>
-              </a:solidFill>
-              <a:latin typeface="Arial" panose="020B0604020202020204" pitchFamily="34" charset="0"/>
-              <a:cs typeface="Arial" panose="020B0604020202020204" pitchFamily="34" charset="0"/>
-            </a:endParaRPr>
-          </a:p>
-        </p:txBody>
-      </p:sp>
-      <p:sp>
-        <p:nvSpPr>
-          <p:cNvPr id="98" name="Rectángulo 97">
-            <a:extLst>
-              <a:ext uri="{FF2B5EF4-FFF2-40B4-BE49-F238E27FC236}">
-                <a16:creationId xmlns:a16="http://schemas.microsoft.com/office/drawing/2014/main" id="{FFC1BFCD-D3E5-2832-A9D9-A5F4B39418C3}"/>
-              </a:ext>
-            </a:extLst>
-          </p:cNvPr>
-          <p:cNvSpPr/>
-          <p:nvPr/>
-        </p:nvSpPr>
-        <p:spPr>
-          <a:xfrm>
-            <a:off x="5566319" y="5509846"/>
-            <a:ext cx="1488825" cy="366346"/>
-          </a:xfrm>
-          <a:prstGeom prst="rect">
-            <a:avLst/>
-          </a:prstGeom>
-          <a:solidFill>
-            <a:schemeClr val="bg1"/>
-          </a:solidFill>
-        </p:spPr>
-        <p:style>
-          <a:lnRef idx="2">
-            <a:schemeClr val="accent1">
-              <a:shade val="15000"/>
-            </a:schemeClr>
-          </a:lnRef>
-          <a:fillRef idx="1">
-            <a:schemeClr val="accent1"/>
-          </a:fillRef>
-          <a:effectRef idx="0">
-            <a:schemeClr val="accent1"/>
-          </a:effectRef>
-          <a:fontRef idx="minor">
-            <a:schemeClr val="lt1"/>
-          </a:fontRef>
-        </p:style>
-        <p:txBody>
-          <a:bodyPr rtlCol="0" anchor="ctr"/>
-          <a:lstStyle/>
-          <a:p>
-            <a:pPr algn="ctr"/>
-            <a:r>
-              <a:rPr lang="es-MX" sz="1200" dirty="0">
-                <a:solidFill>
-                  <a:schemeClr val="tx1"/>
-                </a:solidFill>
-                <a:latin typeface="Arial" panose="020B0604020202020204" pitchFamily="34" charset="0"/>
-                <a:cs typeface="Arial" panose="020B0604020202020204" pitchFamily="34" charset="0"/>
-              </a:rPr>
-              <a:t>Configuración de umbrales</a:t>
-            </a:r>
-            <a:endParaRPr lang="es-CO" sz="1200" dirty="0">
-              <a:solidFill>
-                <a:schemeClr val="tx1"/>
-              </a:solidFill>
-              <a:latin typeface="Arial" panose="020B0604020202020204" pitchFamily="34" charset="0"/>
-              <a:cs typeface="Arial" panose="020B0604020202020204" pitchFamily="34" charset="0"/>
-            </a:endParaRPr>
-          </a:p>
-        </p:txBody>
-      </p:sp>
-      <p:sp>
-        <p:nvSpPr>
-          <p:cNvPr id="99" name="Rectángulo 98">
-            <a:extLst>
-              <a:ext uri="{FF2B5EF4-FFF2-40B4-BE49-F238E27FC236}">
-                <a16:creationId xmlns:a16="http://schemas.microsoft.com/office/drawing/2014/main" id="{B3A6E5BD-271F-F4DC-7288-949E12F52D7B}"/>
-              </a:ext>
-            </a:extLst>
-          </p:cNvPr>
-          <p:cNvSpPr/>
-          <p:nvPr/>
-        </p:nvSpPr>
-        <p:spPr>
-          <a:xfrm>
-            <a:off x="7255647" y="5509846"/>
-            <a:ext cx="1488824" cy="366346"/>
-          </a:xfrm>
-          <a:prstGeom prst="rect">
-            <a:avLst/>
-          </a:prstGeom>
-          <a:solidFill>
-            <a:schemeClr val="bg1"/>
-          </a:solidFill>
-        </p:spPr>
-        <p:style>
-          <a:lnRef idx="2">
-            <a:schemeClr val="accent1">
-              <a:shade val="15000"/>
-            </a:schemeClr>
-          </a:lnRef>
-          <a:fillRef idx="1">
-            <a:schemeClr val="accent1"/>
-          </a:fillRef>
-          <a:effectRef idx="0">
-            <a:schemeClr val="accent1"/>
-          </a:effectRef>
-          <a:fontRef idx="minor">
-            <a:schemeClr val="lt1"/>
-          </a:fontRef>
-        </p:style>
-        <p:txBody>
-          <a:bodyPr rtlCol="0" anchor="ctr"/>
-          <a:lstStyle/>
-          <a:p>
-            <a:pPr algn="ctr"/>
-            <a:r>
-              <a:rPr lang="es-MX" sz="1200" dirty="0">
-                <a:solidFill>
-                  <a:schemeClr val="tx1"/>
-                </a:solidFill>
-                <a:latin typeface="Arial" panose="020B0604020202020204" pitchFamily="34" charset="0"/>
-                <a:cs typeface="Arial" panose="020B0604020202020204" pitchFamily="34" charset="0"/>
-              </a:rPr>
-              <a:t>Configuración de idioma</a:t>
-            </a:r>
-            <a:endParaRPr lang="es-CO" sz="1200" dirty="0">
-              <a:solidFill>
-                <a:schemeClr val="tx1"/>
-              </a:solidFill>
-              <a:latin typeface="Arial" panose="020B0604020202020204" pitchFamily="34" charset="0"/>
-              <a:cs typeface="Arial" panose="020B0604020202020204" pitchFamily="34" charset="0"/>
-            </a:endParaRPr>
-          </a:p>
-        </p:txBody>
-      </p:sp>
-      <p:sp>
-        <p:nvSpPr>
-          <p:cNvPr id="100" name="Rectángulo 99">
-            <a:extLst>
-              <a:ext uri="{FF2B5EF4-FFF2-40B4-BE49-F238E27FC236}">
-                <a16:creationId xmlns:a16="http://schemas.microsoft.com/office/drawing/2014/main" id="{6F607ADD-2345-19F0-5E0F-D5BD0FFB35B7}"/>
-              </a:ext>
-            </a:extLst>
-          </p:cNvPr>
-          <p:cNvSpPr/>
-          <p:nvPr/>
-        </p:nvSpPr>
-        <p:spPr>
-          <a:xfrm>
-            <a:off x="8944974" y="5509846"/>
-            <a:ext cx="1432120" cy="366346"/>
-          </a:xfrm>
-          <a:prstGeom prst="rect">
-            <a:avLst/>
-          </a:prstGeom>
-          <a:solidFill>
-            <a:schemeClr val="bg1"/>
-          </a:solidFill>
-        </p:spPr>
-        <p:style>
-          <a:lnRef idx="2">
-            <a:schemeClr val="accent1">
-              <a:shade val="15000"/>
-            </a:schemeClr>
-          </a:lnRef>
-          <a:fillRef idx="1">
-            <a:schemeClr val="accent1"/>
-          </a:fillRef>
-          <a:effectRef idx="0">
-            <a:schemeClr val="accent1"/>
-          </a:effectRef>
-          <a:fontRef idx="minor">
-            <a:schemeClr val="lt1"/>
-          </a:fontRef>
-        </p:style>
-        <p:txBody>
-          <a:bodyPr rtlCol="0" anchor="ctr"/>
-          <a:lstStyle/>
-          <a:p>
-            <a:pPr algn="ctr"/>
-            <a:r>
-              <a:rPr lang="es-MX" sz="1200" dirty="0">
-                <a:solidFill>
-                  <a:schemeClr val="tx1"/>
-                </a:solidFill>
-                <a:latin typeface="Arial" panose="020B0604020202020204" pitchFamily="34" charset="0"/>
-                <a:cs typeface="Arial" panose="020B0604020202020204" pitchFamily="34" charset="0"/>
-              </a:rPr>
-              <a:t>Configuración de alertas</a:t>
-            </a:r>
-            <a:endParaRPr lang="es-CO" sz="1200" dirty="0">
-              <a:solidFill>
-                <a:schemeClr val="tx1"/>
-              </a:solidFill>
-              <a:latin typeface="Arial" panose="020B0604020202020204" pitchFamily="34" charset="0"/>
-              <a:cs typeface="Arial" panose="020B0604020202020204" pitchFamily="34" charset="0"/>
-            </a:endParaRPr>
-          </a:p>
-        </p:txBody>
-      </p:sp>
-      <p:sp>
-        <p:nvSpPr>
-          <p:cNvPr id="101" name="Rectángulo 100">
-            <a:extLst>
-              <a:ext uri="{FF2B5EF4-FFF2-40B4-BE49-F238E27FC236}">
-                <a16:creationId xmlns:a16="http://schemas.microsoft.com/office/drawing/2014/main" id="{CDC73996-6CD1-B79E-8437-0EFC47D6206C}"/>
-              </a:ext>
-            </a:extLst>
-          </p:cNvPr>
-          <p:cNvSpPr/>
-          <p:nvPr/>
-        </p:nvSpPr>
-        <p:spPr>
-          <a:xfrm>
-            <a:off x="10583496" y="5505450"/>
-            <a:ext cx="1139582" cy="366346"/>
-          </a:xfrm>
-          <a:prstGeom prst="rect">
-            <a:avLst/>
-          </a:prstGeom>
-          <a:solidFill>
-            <a:schemeClr val="bg1"/>
-          </a:solidFill>
-        </p:spPr>
-        <p:style>
-          <a:lnRef idx="2">
-            <a:schemeClr val="accent1">
-              <a:shade val="15000"/>
-            </a:schemeClr>
-          </a:lnRef>
-          <a:fillRef idx="1">
-            <a:schemeClr val="accent1"/>
-          </a:fillRef>
-          <a:effectRef idx="0">
-            <a:schemeClr val="accent1"/>
-          </a:effectRef>
-          <a:fontRef idx="minor">
-            <a:schemeClr val="lt1"/>
-          </a:fontRef>
-        </p:style>
-        <p:txBody>
-          <a:bodyPr rtlCol="0" anchor="ctr"/>
-          <a:lstStyle/>
-          <a:p>
-            <a:pPr algn="ctr"/>
-            <a:r>
-              <a:rPr lang="es-MX" sz="1200" dirty="0">
-                <a:solidFill>
-                  <a:schemeClr val="tx1"/>
-                </a:solidFill>
-                <a:latin typeface="Arial" panose="020B0604020202020204" pitchFamily="34" charset="0"/>
-                <a:cs typeface="Arial" panose="020B0604020202020204" pitchFamily="34" charset="0"/>
-              </a:rPr>
-              <a:t>Configuración de colores</a:t>
-            </a:r>
-            <a:endParaRPr lang="es-CO" sz="1200" dirty="0">
-              <a:solidFill>
-                <a:schemeClr val="tx1"/>
-              </a:solidFill>
-              <a:latin typeface="Arial" panose="020B0604020202020204" pitchFamily="34" charset="0"/>
-              <a:cs typeface="Arial" panose="020B0604020202020204" pitchFamily="34" charset="0"/>
-            </a:endParaRPr>
+              <a:t>Lista de hogares</a:t>
+            </a:r>
           </a:p>
         </p:txBody>
       </p:sp>
       <p:cxnSp>
         <p:nvCxnSpPr>
-          <p:cNvPr id="106" name="Conector recto de flecha 105">
-            <a:extLst>
-              <a:ext uri="{FF2B5EF4-FFF2-40B4-BE49-F238E27FC236}">
-                <a16:creationId xmlns:a16="http://schemas.microsoft.com/office/drawing/2014/main" id="{AB24FD42-3FC9-010F-A82C-EDBF597A8F35}"/>
-              </a:ext>
-            </a:extLst>
-          </p:cNvPr>
-          <p:cNvCxnSpPr>
-            <a:cxnSpLocks/>
-            <a:stCxn id="6" idx="2"/>
-            <a:endCxn id="84" idx="0"/>
-          </p:cNvCxnSpPr>
+          <p:cNvPr id="16" name="Connector 15"/>
+          <p:cNvCxnSpPr/>
           <p:nvPr/>
         </p:nvCxnSpPr>
         <p:spPr>
-          <a:xfrm flipH="1">
-            <a:off x="3470786" y="2206867"/>
-            <a:ext cx="1" cy="278525"/>
-          </a:xfrm>
-          <a:prstGeom prst="straightConnector1">
+          <a:xfrm>
+            <a:off x="2738628" y="1353312"/>
+            <a:ext cx="0" cy="182880"/>
+          </a:xfrm>
+          <a:prstGeom prst="line">
             <a:avLst/>
           </a:prstGeom>
-          <a:ln>
-            <a:headEnd type="triangle"/>
-            <a:tailEnd type="triangle"/>
+          <a:ln w="9525">
+            <a:solidFill>
+              <a:srgbClr val="8FAADC"/>
+            </a:solidFill>
+            <a:tailEnd type="triangle" w="sm" len="sm"/>
           </a:ln>
         </p:spPr>
         <p:style>
@@ -4949,32 +4058,81 @@
           </a:fontRef>
         </p:style>
       </p:cxnSp>
+      <p:sp>
+        <p:nvSpPr>
+          <p:cNvPr id="17" name="Rounded Rectangle 16"/>
+          <p:cNvSpPr/>
+          <p:nvPr/>
+        </p:nvSpPr>
+        <p:spPr>
+          <a:xfrm>
+            <a:off x="1938528" y="1993391"/>
+            <a:ext cx="1600200" cy="365760"/>
+          </a:xfrm>
+          <a:prstGeom prst="roundRect">
+            <a:avLst>
+              <a:gd name="adj" fmla="val 14000"/>
+            </a:avLst>
+          </a:prstGeom>
+          <a:solidFill>
+            <a:srgbClr val="FFFFFF"/>
+          </a:solidFill>
+          <a:ln w="12700">
+            <a:solidFill>
+              <a:srgbClr val="8FAADC"/>
+            </a:solidFill>
+          </a:ln>
+          <a:effectLst/>
+        </p:spPr>
+        <p:style>
+          <a:lnRef idx="1">
+            <a:schemeClr val="accent1"/>
+          </a:lnRef>
+          <a:fillRef idx="3">
+            <a:schemeClr val="accent1"/>
+          </a:fillRef>
+          <a:effectRef idx="2">
+            <a:schemeClr val="accent1"/>
+          </a:effectRef>
+          <a:fontRef idx="minor">
+            <a:schemeClr val="lt1"/>
+          </a:fontRef>
+        </p:style>
+        <p:txBody>
+          <a:bodyPr rtlCol="0" anchor="ctr" wrap="square" lIns="25400" rIns="25400" tIns="0" bIns="0"/>
+          <a:lstStyle/>
+          <a:p>
+            <a:pPr algn="ctr"/>
+            <a:r>
+              <a:rPr sz="950" b="0">
+                <a:solidFill>
+                  <a:srgbClr val="1F3864"/>
+                </a:solidFill>
+              </a:rPr>
+              <a:t>Crear hogar</a:t>
+            </a:r>
+          </a:p>
+        </p:txBody>
+      </p:sp>
       <p:cxnSp>
         <p:nvCxnSpPr>
-          <p:cNvPr id="109" name="Conector recto de flecha 108">
-            <a:extLst>
-              <a:ext uri="{FF2B5EF4-FFF2-40B4-BE49-F238E27FC236}">
-                <a16:creationId xmlns:a16="http://schemas.microsoft.com/office/drawing/2014/main" id="{89FF7A20-65C6-6663-EA5B-61D2BD6B06AE}"/>
-              </a:ext>
-            </a:extLst>
-          </p:cNvPr>
-          <p:cNvCxnSpPr>
-            <a:stCxn id="84" idx="2"/>
-            <a:endCxn id="96" idx="0"/>
-          </p:cNvCxnSpPr>
+          <p:cNvPr id="18" name="Connector 17"/>
+          <p:cNvCxnSpPr/>
           <p:nvPr/>
         </p:nvCxnSpPr>
         <p:spPr>
           <a:xfrm>
-            <a:off x="3470786" y="2851738"/>
-            <a:ext cx="0" cy="250904"/>
-          </a:xfrm>
-          <a:prstGeom prst="straightConnector1">
+            <a:off x="2738628" y="1353312"/>
+            <a:ext cx="0" cy="640079"/>
+          </a:xfrm>
+          <a:prstGeom prst="line">
             <a:avLst/>
           </a:prstGeom>
-          <a:ln>
-            <a:headEnd type="triangle"/>
-            <a:tailEnd type="triangle"/>
+          <a:ln w="9525">
+            <a:solidFill>
+              <a:srgbClr val="8FAADC"/>
+            </a:solidFill>
+            <a:tailEnd type="triangle" w="sm" len="sm"/>
           </a:ln>
         </p:spPr>
         <p:style>
@@ -4992,32 +4150,81 @@
           </a:fontRef>
         </p:style>
       </p:cxnSp>
+      <p:sp>
+        <p:nvSpPr>
+          <p:cNvPr id="19" name="Rounded Rectangle 18"/>
+          <p:cNvSpPr/>
+          <p:nvPr/>
+        </p:nvSpPr>
+        <p:spPr>
+          <a:xfrm>
+            <a:off x="1938528" y="2450591"/>
+            <a:ext cx="1600200" cy="365760"/>
+          </a:xfrm>
+          <a:prstGeom prst="roundRect">
+            <a:avLst>
+              <a:gd name="adj" fmla="val 14000"/>
+            </a:avLst>
+          </a:prstGeom>
+          <a:solidFill>
+            <a:srgbClr val="FFFFFF"/>
+          </a:solidFill>
+          <a:ln w="12700">
+            <a:solidFill>
+              <a:srgbClr val="8FAADC"/>
+            </a:solidFill>
+          </a:ln>
+          <a:effectLst/>
+        </p:spPr>
+        <p:style>
+          <a:lnRef idx="1">
+            <a:schemeClr val="accent1"/>
+          </a:lnRef>
+          <a:fillRef idx="3">
+            <a:schemeClr val="accent1"/>
+          </a:fillRef>
+          <a:effectRef idx="2">
+            <a:schemeClr val="accent1"/>
+          </a:effectRef>
+          <a:fontRef idx="minor">
+            <a:schemeClr val="lt1"/>
+          </a:fontRef>
+        </p:style>
+        <p:txBody>
+          <a:bodyPr rtlCol="0" anchor="ctr" wrap="square" lIns="25400" rIns="25400" tIns="0" bIns="0"/>
+          <a:lstStyle/>
+          <a:p>
+            <a:pPr algn="ctr"/>
+            <a:r>
+              <a:rPr sz="950" b="0">
+                <a:solidFill>
+                  <a:srgbClr val="1F3864"/>
+                </a:solidFill>
+              </a:rPr>
+              <a:t>Unirse a hogar</a:t>
+            </a:r>
+          </a:p>
+        </p:txBody>
+      </p:sp>
       <p:cxnSp>
         <p:nvCxnSpPr>
-          <p:cNvPr id="112" name="Conector recto de flecha 111">
-            <a:extLst>
-              <a:ext uri="{FF2B5EF4-FFF2-40B4-BE49-F238E27FC236}">
-                <a16:creationId xmlns:a16="http://schemas.microsoft.com/office/drawing/2014/main" id="{BE7D8650-D9DF-601D-659C-F57C8762158C}"/>
-              </a:ext>
-            </a:extLst>
-          </p:cNvPr>
-          <p:cNvCxnSpPr>
-            <a:stCxn id="96" idx="2"/>
-            <a:endCxn id="97" idx="0"/>
-          </p:cNvCxnSpPr>
+          <p:cNvPr id="20" name="Connector 19"/>
+          <p:cNvCxnSpPr/>
           <p:nvPr/>
         </p:nvCxnSpPr>
         <p:spPr>
-          <a:xfrm flipH="1">
-            <a:off x="3466007" y="3468988"/>
-            <a:ext cx="4779" cy="250904"/>
-          </a:xfrm>
-          <a:prstGeom prst="straightConnector1">
+          <a:xfrm>
+            <a:off x="2738628" y="1353312"/>
+            <a:ext cx="0" cy="1097279"/>
+          </a:xfrm>
+          <a:prstGeom prst="line">
             <a:avLst/>
           </a:prstGeom>
-          <a:ln>
-            <a:headEnd type="triangle"/>
-            <a:tailEnd type="triangle"/>
+          <a:ln w="9525">
+            <a:solidFill>
+              <a:srgbClr val="8FAADC"/>
+            </a:solidFill>
+            <a:tailEnd type="triangle" w="sm" len="sm"/>
           </a:ln>
         </p:spPr>
         <p:style>
@@ -5037,43 +4244,38 @@
       </p:cxnSp>
       <p:sp>
         <p:nvSpPr>
-          <p:cNvPr id="114" name="Rectángulo 113">
-            <a:extLst>
-              <a:ext uri="{FF2B5EF4-FFF2-40B4-BE49-F238E27FC236}">
-                <a16:creationId xmlns:a16="http://schemas.microsoft.com/office/drawing/2014/main" id="{1D58E0AE-A5DF-C126-3F08-F5D716FC5B70}"/>
-              </a:ext>
-            </a:extLst>
-          </p:cNvPr>
+          <p:cNvPr id="21" name="Rounded Rectangle 20"/>
           <p:cNvSpPr/>
           <p:nvPr/>
         </p:nvSpPr>
         <p:spPr>
           <a:xfrm>
-            <a:off x="704559" y="5590654"/>
-            <a:ext cx="4394979" cy="526283"/>
-          </a:xfrm>
-          <a:prstGeom prst="rect">
-            <a:avLst/>
+            <a:off x="3648456" y="896112"/>
+            <a:ext cx="1600200" cy="457200"/>
+          </a:xfrm>
+          <a:prstGeom prst="roundRect">
+            <a:avLst>
+              <a:gd name="adj" fmla="val 14000"/>
+            </a:avLst>
           </a:prstGeom>
           <a:solidFill>
-            <a:srgbClr val="FF0000"/>
+            <a:srgbClr val="1F4E79"/>
           </a:solidFill>
-          <a:ln>
+          <a:ln w="12700">
             <a:solidFill>
-              <a:schemeClr val="tx1"/>
+              <a:srgbClr val="1F4E79"/>
             </a:solidFill>
           </a:ln>
+          <a:effectLst/>
         </p:spPr>
         <p:style>
-          <a:lnRef idx="2">
-            <a:schemeClr val="accent1">
-              <a:shade val="15000"/>
-            </a:schemeClr>
+          <a:lnRef idx="1">
+            <a:schemeClr val="accent1"/>
           </a:lnRef>
-          <a:fillRef idx="1">
+          <a:fillRef idx="3">
             <a:schemeClr val="accent1"/>
           </a:fillRef>
-          <a:effectRef idx="0">
+          <a:effectRef idx="2">
             <a:schemeClr val="accent1"/>
           </a:effectRef>
           <a:fontRef idx="minor">
@@ -5081,59 +4283,40 @@
           </a:fontRef>
         </p:style>
         <p:txBody>
-          <a:bodyPr rtlCol="0" anchor="ctr"/>
+          <a:bodyPr rtlCol="0" anchor="ctr" wrap="square" lIns="25400" rIns="25400" tIns="0" bIns="0"/>
           <a:lstStyle/>
           <a:p>
             <a:pPr algn="ctr"/>
             <a:r>
-              <a:rPr lang="es-MX" sz="1600" dirty="0">
+              <a:rPr sz="1100" b="1">
                 <a:solidFill>
-                  <a:schemeClr val="tx1"/>
+                  <a:srgbClr val="FFFFFF"/>
                 </a:solidFill>
-                <a:latin typeface="Arial" panose="020B0604020202020204" pitchFamily="34" charset="0"/>
-                <a:cs typeface="Arial" panose="020B0604020202020204" pitchFamily="34" charset="0"/>
               </a:rPr>
-              <a:t>Las pantallas de rojo son únicamente accesibles por el usuario responsable.</a:t>
-            </a:r>
-            <a:endParaRPr lang="es-CO" sz="1600" dirty="0">
-              <a:solidFill>
-                <a:schemeClr val="tx1"/>
-              </a:solidFill>
-              <a:latin typeface="Arial" panose="020B0604020202020204" pitchFamily="34" charset="0"/>
-              <a:cs typeface="Arial" panose="020B0604020202020204" pitchFamily="34" charset="0"/>
-            </a:endParaRPr>
+              <a:t>Hogares</a:t>
+            </a:r>
           </a:p>
         </p:txBody>
       </p:sp>
       <p:cxnSp>
         <p:nvCxnSpPr>
-          <p:cNvPr id="118" name="Conector: angular 117">
-            <a:extLst>
-              <a:ext uri="{FF2B5EF4-FFF2-40B4-BE49-F238E27FC236}">
-                <a16:creationId xmlns:a16="http://schemas.microsoft.com/office/drawing/2014/main" id="{42631476-B5A6-E9B6-6B39-6A3C2EF8576D}"/>
-              </a:ext>
-            </a:extLst>
-          </p:cNvPr>
-          <p:cNvCxnSpPr>
-            <a:cxnSpLocks/>
-            <a:stCxn id="17" idx="2"/>
-            <a:endCxn id="98" idx="0"/>
-          </p:cNvCxnSpPr>
+          <p:cNvPr id="22" name="Connector 21"/>
+          <p:cNvCxnSpPr/>
           <p:nvPr/>
         </p:nvCxnSpPr>
         <p:spPr>
-          <a:xfrm rot="5400000">
-            <a:off x="6692425" y="1825175"/>
-            <a:ext cx="3302979" cy="4066363"/>
-          </a:xfrm>
-          <a:prstGeom prst="bentConnector3">
-            <a:avLst>
-              <a:gd name="adj1" fmla="val 83008"/>
-            </a:avLst>
-          </a:prstGeom>
-          <a:ln>
-            <a:headEnd type="triangle"/>
-            <a:tailEnd type="triangle"/>
+          <a:xfrm>
+            <a:off x="4448556" y="704088"/>
+            <a:ext cx="0" cy="192024"/>
+          </a:xfrm>
+          <a:prstGeom prst="line">
+            <a:avLst/>
+          </a:prstGeom>
+          <a:ln w="9525">
+            <a:solidFill>
+              <a:srgbClr val="BDD7EE"/>
+            </a:solidFill>
+            <a:tailEnd type="triangle" w="sm" len="sm"/>
           </a:ln>
         </p:spPr>
         <p:style>
@@ -5151,35 +4334,81 @@
           </a:fontRef>
         </p:style>
       </p:cxnSp>
+      <p:sp>
+        <p:nvSpPr>
+          <p:cNvPr id="23" name="Rounded Rectangle 22"/>
+          <p:cNvSpPr/>
+          <p:nvPr/>
+        </p:nvSpPr>
+        <p:spPr>
+          <a:xfrm>
+            <a:off x="3648456" y="1536192"/>
+            <a:ext cx="1600200" cy="365760"/>
+          </a:xfrm>
+          <a:prstGeom prst="roundRect">
+            <a:avLst>
+              <a:gd name="adj" fmla="val 14000"/>
+            </a:avLst>
+          </a:prstGeom>
+          <a:solidFill>
+            <a:srgbClr val="FFFFFF"/>
+          </a:solidFill>
+          <a:ln w="12700">
+            <a:solidFill>
+              <a:srgbClr val="8FAADC"/>
+            </a:solidFill>
+          </a:ln>
+          <a:effectLst/>
+        </p:spPr>
+        <p:style>
+          <a:lnRef idx="1">
+            <a:schemeClr val="accent1"/>
+          </a:lnRef>
+          <a:fillRef idx="3">
+            <a:schemeClr val="accent1"/>
+          </a:fillRef>
+          <a:effectRef idx="2">
+            <a:schemeClr val="accent1"/>
+          </a:effectRef>
+          <a:fontRef idx="minor">
+            <a:schemeClr val="lt1"/>
+          </a:fontRef>
+        </p:style>
+        <p:txBody>
+          <a:bodyPr rtlCol="0" anchor="ctr" wrap="square" lIns="25400" rIns="25400" tIns="0" bIns="0"/>
+          <a:lstStyle/>
+          <a:p>
+            <a:pPr algn="ctr"/>
+            <a:r>
+              <a:rPr sz="950" b="1">
+                <a:solidFill>
+                  <a:srgbClr val="1F3864"/>
+                </a:solidFill>
+              </a:rPr>
+              <a:t>Detalle del hogar</a:t>
+            </a:r>
+          </a:p>
+        </p:txBody>
+      </p:sp>
       <p:cxnSp>
         <p:nvCxnSpPr>
-          <p:cNvPr id="122" name="Conector: angular 121">
-            <a:extLst>
-              <a:ext uri="{FF2B5EF4-FFF2-40B4-BE49-F238E27FC236}">
-                <a16:creationId xmlns:a16="http://schemas.microsoft.com/office/drawing/2014/main" id="{682506C9-B32C-C401-C644-E1A906DAE421}"/>
-              </a:ext>
-            </a:extLst>
-          </p:cNvPr>
-          <p:cNvCxnSpPr>
-            <a:cxnSpLocks/>
-            <a:stCxn id="17" idx="2"/>
-            <a:endCxn id="99" idx="0"/>
-          </p:cNvCxnSpPr>
+          <p:cNvPr id="24" name="Connector 23"/>
+          <p:cNvCxnSpPr/>
           <p:nvPr/>
         </p:nvCxnSpPr>
         <p:spPr>
-          <a:xfrm rot="5400000">
-            <a:off x="7537088" y="2669838"/>
-            <a:ext cx="3302979" cy="2377036"/>
-          </a:xfrm>
-          <a:prstGeom prst="bentConnector3">
-            <a:avLst>
-              <a:gd name="adj1" fmla="val 83363"/>
-            </a:avLst>
-          </a:prstGeom>
-          <a:ln>
-            <a:headEnd type="triangle"/>
-            <a:tailEnd type="triangle"/>
+          <a:xfrm>
+            <a:off x="4448556" y="1353312"/>
+            <a:ext cx="0" cy="182880"/>
+          </a:xfrm>
+          <a:prstGeom prst="line">
+            <a:avLst/>
+          </a:prstGeom>
+          <a:ln w="9525">
+            <a:solidFill>
+              <a:srgbClr val="8FAADC"/>
+            </a:solidFill>
+            <a:tailEnd type="triangle" w="sm" len="sm"/>
           </a:ln>
         </p:spPr>
         <p:style>
@@ -5197,35 +4426,81 @@
           </a:fontRef>
         </p:style>
       </p:cxnSp>
+      <p:sp>
+        <p:nvSpPr>
+          <p:cNvPr id="25" name="Rounded Rectangle 24"/>
+          <p:cNvSpPr/>
+          <p:nvPr/>
+        </p:nvSpPr>
+        <p:spPr>
+          <a:xfrm>
+            <a:off x="3648456" y="1993391"/>
+            <a:ext cx="1600200" cy="365760"/>
+          </a:xfrm>
+          <a:prstGeom prst="roundRect">
+            <a:avLst>
+              <a:gd name="adj" fmla="val 14000"/>
+            </a:avLst>
+          </a:prstGeom>
+          <a:solidFill>
+            <a:srgbClr val="FFFFFF"/>
+          </a:solidFill>
+          <a:ln w="12700">
+            <a:solidFill>
+              <a:srgbClr val="8FAADC"/>
+            </a:solidFill>
+          </a:ln>
+          <a:effectLst/>
+        </p:spPr>
+        <p:style>
+          <a:lnRef idx="1">
+            <a:schemeClr val="accent1"/>
+          </a:lnRef>
+          <a:fillRef idx="3">
+            <a:schemeClr val="accent1"/>
+          </a:fillRef>
+          <a:effectRef idx="2">
+            <a:schemeClr val="accent1"/>
+          </a:effectRef>
+          <a:fontRef idx="minor">
+            <a:schemeClr val="lt1"/>
+          </a:fontRef>
+        </p:style>
+        <p:txBody>
+          <a:bodyPr rtlCol="0" anchor="ctr" wrap="square" lIns="25400" rIns="25400" tIns="0" bIns="0"/>
+          <a:lstStyle/>
+          <a:p>
+            <a:pPr algn="ctr"/>
+            <a:r>
+              <a:rPr sz="950" b="0">
+                <a:solidFill>
+                  <a:srgbClr val="1F3864"/>
+                </a:solidFill>
+              </a:rPr>
+              <a:t>Consumo</a:t>
+            </a:r>
+          </a:p>
+        </p:txBody>
+      </p:sp>
       <p:cxnSp>
         <p:nvCxnSpPr>
-          <p:cNvPr id="127" name="Conector: angular 126">
-            <a:extLst>
-              <a:ext uri="{FF2B5EF4-FFF2-40B4-BE49-F238E27FC236}">
-                <a16:creationId xmlns:a16="http://schemas.microsoft.com/office/drawing/2014/main" id="{B9E66EF7-B5D7-EF24-9954-DD0D6790048B}"/>
-              </a:ext>
-            </a:extLst>
-          </p:cNvPr>
-          <p:cNvCxnSpPr>
-            <a:cxnSpLocks/>
-            <a:stCxn id="17" idx="2"/>
-            <a:endCxn id="100" idx="0"/>
-          </p:cNvCxnSpPr>
+          <p:cNvPr id="26" name="Connector 25"/>
+          <p:cNvCxnSpPr/>
           <p:nvPr/>
         </p:nvCxnSpPr>
         <p:spPr>
-          <a:xfrm rot="5400000">
-            <a:off x="8367576" y="3500326"/>
-            <a:ext cx="3302979" cy="716061"/>
-          </a:xfrm>
-          <a:prstGeom prst="bentConnector3">
-            <a:avLst>
-              <a:gd name="adj1" fmla="val 83363"/>
-            </a:avLst>
-          </a:prstGeom>
-          <a:ln>
-            <a:headEnd type="triangle"/>
-            <a:tailEnd type="triangle"/>
+          <a:xfrm>
+            <a:off x="4448556" y="1353312"/>
+            <a:ext cx="0" cy="640079"/>
+          </a:xfrm>
+          <a:prstGeom prst="line">
+            <a:avLst/>
+          </a:prstGeom>
+          <a:ln w="9525">
+            <a:solidFill>
+              <a:srgbClr val="8FAADC"/>
+            </a:solidFill>
+            <a:tailEnd type="triangle" w="sm" len="sm"/>
           </a:ln>
         </p:spPr>
         <p:style>
@@ -5243,35 +4518,81 @@
           </a:fontRef>
         </p:style>
       </p:cxnSp>
+      <p:sp>
+        <p:nvSpPr>
+          <p:cNvPr id="27" name="Rounded Rectangle 26"/>
+          <p:cNvSpPr/>
+          <p:nvPr/>
+        </p:nvSpPr>
+        <p:spPr>
+          <a:xfrm>
+            <a:off x="3648456" y="2450591"/>
+            <a:ext cx="1600200" cy="365760"/>
+          </a:xfrm>
+          <a:prstGeom prst="roundRect">
+            <a:avLst>
+              <a:gd name="adj" fmla="val 14000"/>
+            </a:avLst>
+          </a:prstGeom>
+          <a:solidFill>
+            <a:srgbClr val="FFFFFF"/>
+          </a:solidFill>
+          <a:ln w="12700">
+            <a:solidFill>
+              <a:srgbClr val="8FAADC"/>
+            </a:solidFill>
+          </a:ln>
+          <a:effectLst/>
+        </p:spPr>
+        <p:style>
+          <a:lnRef idx="1">
+            <a:schemeClr val="accent1"/>
+          </a:lnRef>
+          <a:fillRef idx="3">
+            <a:schemeClr val="accent1"/>
+          </a:fillRef>
+          <a:effectRef idx="2">
+            <a:schemeClr val="accent1"/>
+          </a:effectRef>
+          <a:fontRef idx="minor">
+            <a:schemeClr val="lt1"/>
+          </a:fontRef>
+        </p:style>
+        <p:txBody>
+          <a:bodyPr rtlCol="0" anchor="ctr" wrap="square" lIns="25400" rIns="25400" tIns="0" bIns="0"/>
+          <a:lstStyle/>
+          <a:p>
+            <a:pPr algn="ctr"/>
+            <a:r>
+              <a:rPr sz="950" b="0">
+                <a:solidFill>
+                  <a:srgbClr val="1F3864"/>
+                </a:solidFill>
+              </a:rPr>
+              <a:t>Historial</a:t>
+            </a:r>
+          </a:p>
+        </p:txBody>
+      </p:sp>
       <p:cxnSp>
         <p:nvCxnSpPr>
-          <p:cNvPr id="131" name="Conector: angular 130">
-            <a:extLst>
-              <a:ext uri="{FF2B5EF4-FFF2-40B4-BE49-F238E27FC236}">
-                <a16:creationId xmlns:a16="http://schemas.microsoft.com/office/drawing/2014/main" id="{01E0B02B-A39E-D3A2-BE06-76A659E12EBA}"/>
-              </a:ext>
-            </a:extLst>
-          </p:cNvPr>
-          <p:cNvCxnSpPr>
-            <a:cxnSpLocks/>
-            <a:stCxn id="17" idx="2"/>
-            <a:endCxn id="101" idx="0"/>
-          </p:cNvCxnSpPr>
+          <p:cNvPr id="28" name="Connector 27"/>
+          <p:cNvCxnSpPr/>
           <p:nvPr/>
         </p:nvCxnSpPr>
         <p:spPr>
-          <a:xfrm rot="16200000" flipH="1">
-            <a:off x="9115900" y="3468062"/>
-            <a:ext cx="3298583" cy="776192"/>
-          </a:xfrm>
-          <a:prstGeom prst="bentConnector3">
-            <a:avLst>
-              <a:gd name="adj1" fmla="val 83407"/>
-            </a:avLst>
-          </a:prstGeom>
-          <a:ln>
-            <a:headEnd type="triangle"/>
-            <a:tailEnd type="triangle"/>
+          <a:xfrm>
+            <a:off x="4448556" y="1353312"/>
+            <a:ext cx="0" cy="1097279"/>
+          </a:xfrm>
+          <a:prstGeom prst="line">
+            <a:avLst/>
+          </a:prstGeom>
+          <a:ln w="9525">
+            <a:solidFill>
+              <a:srgbClr val="8FAADC"/>
+            </a:solidFill>
+            <a:tailEnd type="triangle" w="sm" len="sm"/>
           </a:ln>
         </p:spPr>
         <p:style>
@@ -5291,35 +4612,38 @@
       </p:cxnSp>
       <p:sp>
         <p:nvSpPr>
-          <p:cNvPr id="36" name="Rectángulo 35">
-            <a:extLst>
-              <a:ext uri="{FF2B5EF4-FFF2-40B4-BE49-F238E27FC236}">
-                <a16:creationId xmlns:a16="http://schemas.microsoft.com/office/drawing/2014/main" id="{C4B17611-490A-1F4B-F2A4-717609A5C68A}"/>
-              </a:ext>
-            </a:extLst>
-          </p:cNvPr>
+          <p:cNvPr id="29" name="Rounded Rectangle 28"/>
           <p:cNvSpPr/>
           <p:nvPr/>
         </p:nvSpPr>
         <p:spPr>
           <a:xfrm>
-            <a:off x="5097809" y="668587"/>
-            <a:ext cx="1996382" cy="328246"/>
-          </a:xfrm>
-          <a:prstGeom prst="rect">
-            <a:avLst/>
-          </a:prstGeom>
+            <a:off x="3648456" y="2907791"/>
+            <a:ext cx="1600200" cy="365760"/>
+          </a:xfrm>
+          <a:prstGeom prst="roundRect">
+            <a:avLst>
+              <a:gd name="adj" fmla="val 14000"/>
+            </a:avLst>
+          </a:prstGeom>
+          <a:solidFill>
+            <a:srgbClr val="FFFFFF"/>
+          </a:solidFill>
+          <a:ln w="12700">
+            <a:solidFill>
+              <a:srgbClr val="C00000"/>
+            </a:solidFill>
+          </a:ln>
+          <a:effectLst/>
         </p:spPr>
         <p:style>
-          <a:lnRef idx="2">
-            <a:schemeClr val="accent1">
-              <a:shade val="15000"/>
-            </a:schemeClr>
+          <a:lnRef idx="1">
+            <a:schemeClr val="accent1"/>
           </a:lnRef>
-          <a:fillRef idx="1">
+          <a:fillRef idx="3">
             <a:schemeClr val="accent1"/>
           </a:fillRef>
-          <a:effectRef idx="0">
+          <a:effectRef idx="2">
             <a:schemeClr val="accent1"/>
           </a:effectRef>
           <a:fontRef idx="minor">
@@ -5327,50 +4651,40 @@
           </a:fontRef>
         </p:style>
         <p:txBody>
-          <a:bodyPr rtlCol="0" anchor="ctr"/>
+          <a:bodyPr rtlCol="0" anchor="ctr" wrap="square" lIns="25400" rIns="25400" tIns="0" bIns="0"/>
           <a:lstStyle/>
           <a:p>
             <a:pPr algn="ctr"/>
             <a:r>
-              <a:rPr lang="es-MX" sz="1600" dirty="0">
-                <a:latin typeface="Arial" panose="020B0604020202020204" pitchFamily="34" charset="0"/>
-                <a:cs typeface="Arial" panose="020B0604020202020204" pitchFamily="34" charset="0"/>
+              <a:rPr sz="950" b="0">
+                <a:solidFill>
+                  <a:srgbClr val="C00000"/>
+                </a:solidFill>
               </a:rPr>
-              <a:t>Dashboard</a:t>
-            </a:r>
-            <a:endParaRPr lang="es-CO" sz="1600" dirty="0">
-              <a:latin typeface="Arial" panose="020B0604020202020204" pitchFamily="34" charset="0"/>
-              <a:cs typeface="Arial" panose="020B0604020202020204" pitchFamily="34" charset="0"/>
-            </a:endParaRPr>
+              <a:t>Usuarios</a:t>
+            </a:r>
           </a:p>
         </p:txBody>
       </p:sp>
       <p:cxnSp>
         <p:nvCxnSpPr>
-          <p:cNvPr id="39" name="Conector: angular 38">
-            <a:extLst>
-              <a:ext uri="{FF2B5EF4-FFF2-40B4-BE49-F238E27FC236}">
-                <a16:creationId xmlns:a16="http://schemas.microsoft.com/office/drawing/2014/main" id="{ECD7567A-9780-6D33-535F-4AA8B7A4862A}"/>
-              </a:ext>
-            </a:extLst>
-          </p:cNvPr>
-          <p:cNvCxnSpPr>
-            <a:stCxn id="4" idx="2"/>
-            <a:endCxn id="20" idx="0"/>
-          </p:cNvCxnSpPr>
+          <p:cNvPr id="30" name="Connector 29"/>
+          <p:cNvCxnSpPr/>
           <p:nvPr/>
         </p:nvCxnSpPr>
         <p:spPr>
-          <a:xfrm rot="5400000">
-            <a:off x="3611997" y="-491081"/>
-            <a:ext cx="389421" cy="4578586"/>
-          </a:xfrm>
-          <a:prstGeom prst="bentConnector3">
+          <a:xfrm>
+            <a:off x="4448556" y="1353312"/>
+            <a:ext cx="0" cy="1554479"/>
+          </a:xfrm>
+          <a:prstGeom prst="line">
             <a:avLst/>
           </a:prstGeom>
-          <a:ln>
-            <a:headEnd type="triangle"/>
-            <a:tailEnd type="triangle"/>
+          <a:ln w="9525">
+            <a:solidFill>
+              <a:srgbClr val="C00000"/>
+            </a:solidFill>
+            <a:tailEnd type="triangle" w="sm" len="sm"/>
           </a:ln>
         </p:spPr>
         <p:style>
@@ -5388,35 +4702,81 @@
           </a:fontRef>
         </p:style>
       </p:cxnSp>
+      <p:sp>
+        <p:nvSpPr>
+          <p:cNvPr id="31" name="Rounded Rectangle 30"/>
+          <p:cNvSpPr/>
+          <p:nvPr/>
+        </p:nvSpPr>
+        <p:spPr>
+          <a:xfrm>
+            <a:off x="3648456" y="3364991"/>
+            <a:ext cx="1600200" cy="365760"/>
+          </a:xfrm>
+          <a:prstGeom prst="roundRect">
+            <a:avLst>
+              <a:gd name="adj" fmla="val 14000"/>
+            </a:avLst>
+          </a:prstGeom>
+          <a:solidFill>
+            <a:srgbClr val="FFFFFF"/>
+          </a:solidFill>
+          <a:ln w="12700">
+            <a:solidFill>
+              <a:srgbClr val="C00000"/>
+            </a:solidFill>
+          </a:ln>
+          <a:effectLst/>
+        </p:spPr>
+        <p:style>
+          <a:lnRef idx="1">
+            <a:schemeClr val="accent1"/>
+          </a:lnRef>
+          <a:fillRef idx="3">
+            <a:schemeClr val="accent1"/>
+          </a:fillRef>
+          <a:effectRef idx="2">
+            <a:schemeClr val="accent1"/>
+          </a:effectRef>
+          <a:fontRef idx="minor">
+            <a:schemeClr val="lt1"/>
+          </a:fontRef>
+        </p:style>
+        <p:txBody>
+          <a:bodyPr rtlCol="0" anchor="ctr" wrap="square" lIns="25400" rIns="25400" tIns="0" bIns="0"/>
+          <a:lstStyle/>
+          <a:p>
+            <a:pPr algn="ctr"/>
+            <a:r>
+              <a:rPr sz="950" b="0">
+                <a:solidFill>
+                  <a:srgbClr val="C00000"/>
+                </a:solidFill>
+              </a:rPr>
+              <a:t>Dispositivos</a:t>
+            </a:r>
+          </a:p>
+        </p:txBody>
+      </p:sp>
       <p:cxnSp>
         <p:nvCxnSpPr>
-          <p:cNvPr id="42" name="Conector: angular 41">
-            <a:extLst>
-              <a:ext uri="{FF2B5EF4-FFF2-40B4-BE49-F238E27FC236}">
-                <a16:creationId xmlns:a16="http://schemas.microsoft.com/office/drawing/2014/main" id="{00C6FA82-F297-AE15-B344-38D26D648737}"/>
-              </a:ext>
-            </a:extLst>
-          </p:cNvPr>
-          <p:cNvCxnSpPr>
-            <a:cxnSpLocks/>
-            <a:stCxn id="4" idx="2"/>
-            <a:endCxn id="6" idx="0"/>
-          </p:cNvCxnSpPr>
+          <p:cNvPr id="32" name="Connector 31"/>
+          <p:cNvCxnSpPr/>
           <p:nvPr/>
         </p:nvCxnSpPr>
         <p:spPr>
-          <a:xfrm rot="5400000">
-            <a:off x="4588684" y="485606"/>
-            <a:ext cx="389420" cy="2625213"/>
-          </a:xfrm>
-          <a:prstGeom prst="bentConnector3">
-            <a:avLst>
-              <a:gd name="adj1" fmla="val 50000"/>
-            </a:avLst>
-          </a:prstGeom>
-          <a:ln>
-            <a:headEnd type="triangle"/>
-            <a:tailEnd type="triangle"/>
+          <a:xfrm>
+            <a:off x="4448556" y="1353312"/>
+            <a:ext cx="0" cy="2011679"/>
+          </a:xfrm>
+          <a:prstGeom prst="line">
+            <a:avLst/>
+          </a:prstGeom>
+          <a:ln w="9525">
+            <a:solidFill>
+              <a:srgbClr val="C00000"/>
+            </a:solidFill>
+            <a:tailEnd type="triangle" w="sm" len="sm"/>
           </a:ln>
         </p:spPr>
         <p:style>
@@ -5434,32 +4794,81 @@
           </a:fontRef>
         </p:style>
       </p:cxnSp>
+      <p:sp>
+        <p:nvSpPr>
+          <p:cNvPr id="33" name="Rounded Rectangle 32"/>
+          <p:cNvSpPr/>
+          <p:nvPr/>
+        </p:nvSpPr>
+        <p:spPr>
+          <a:xfrm>
+            <a:off x="3648456" y="3822191"/>
+            <a:ext cx="1600200" cy="365760"/>
+          </a:xfrm>
+          <a:prstGeom prst="roundRect">
+            <a:avLst>
+              <a:gd name="adj" fmla="val 14000"/>
+            </a:avLst>
+          </a:prstGeom>
+          <a:solidFill>
+            <a:srgbClr val="FFFFFF"/>
+          </a:solidFill>
+          <a:ln w="12700">
+            <a:solidFill>
+              <a:srgbClr val="C00000"/>
+            </a:solidFill>
+          </a:ln>
+          <a:effectLst/>
+        </p:spPr>
+        <p:style>
+          <a:lnRef idx="1">
+            <a:schemeClr val="accent1"/>
+          </a:lnRef>
+          <a:fillRef idx="3">
+            <a:schemeClr val="accent1"/>
+          </a:fillRef>
+          <a:effectRef idx="2">
+            <a:schemeClr val="accent1"/>
+          </a:effectRef>
+          <a:fontRef idx="minor">
+            <a:schemeClr val="lt1"/>
+          </a:fontRef>
+        </p:style>
+        <p:txBody>
+          <a:bodyPr rtlCol="0" anchor="ctr" wrap="square" lIns="25400" rIns="25400" tIns="0" bIns="0"/>
+          <a:lstStyle/>
+          <a:p>
+            <a:pPr algn="ctr"/>
+            <a:r>
+              <a:rPr sz="950" b="0">
+                <a:solidFill>
+                  <a:srgbClr val="C00000"/>
+                </a:solidFill>
+              </a:rPr>
+              <a:t>Umbrales</a:t>
+            </a:r>
+          </a:p>
+        </p:txBody>
+      </p:sp>
       <p:cxnSp>
         <p:nvCxnSpPr>
-          <p:cNvPr id="45" name="Conector: angular 44">
-            <a:extLst>
-              <a:ext uri="{FF2B5EF4-FFF2-40B4-BE49-F238E27FC236}">
-                <a16:creationId xmlns:a16="http://schemas.microsoft.com/office/drawing/2014/main" id="{5D4AA0D3-B6A5-39F1-6883-8A19B928F74D}"/>
-              </a:ext>
-            </a:extLst>
-          </p:cNvPr>
-          <p:cNvCxnSpPr>
-            <a:stCxn id="4" idx="2"/>
-            <a:endCxn id="29" idx="0"/>
-          </p:cNvCxnSpPr>
+          <p:cNvPr id="34" name="Connector 33"/>
+          <p:cNvCxnSpPr/>
           <p:nvPr/>
         </p:nvCxnSpPr>
         <p:spPr>
-          <a:xfrm rot="5400000">
-            <a:off x="5505655" y="1402577"/>
-            <a:ext cx="389420" cy="791270"/>
-          </a:xfrm>
-          <a:prstGeom prst="bentConnector3">
+          <a:xfrm>
+            <a:off x="4448556" y="1353312"/>
+            <a:ext cx="0" cy="2468879"/>
+          </a:xfrm>
+          <a:prstGeom prst="line">
             <a:avLst/>
           </a:prstGeom>
-          <a:ln>
-            <a:headEnd type="triangle"/>
-            <a:tailEnd type="triangle"/>
+          <a:ln w="9525">
+            <a:solidFill>
+              <a:srgbClr val="C00000"/>
+            </a:solidFill>
+            <a:tailEnd type="triangle" w="sm" len="sm"/>
           </a:ln>
         </p:spPr>
         <p:style>
@@ -5477,32 +4886,81 @@
           </a:fontRef>
         </p:style>
       </p:cxnSp>
+      <p:sp>
+        <p:nvSpPr>
+          <p:cNvPr id="35" name="Rounded Rectangle 34"/>
+          <p:cNvSpPr/>
+          <p:nvPr/>
+        </p:nvSpPr>
+        <p:spPr>
+          <a:xfrm>
+            <a:off x="3648456" y="4279392"/>
+            <a:ext cx="1600200" cy="365760"/>
+          </a:xfrm>
+          <a:prstGeom prst="roundRect">
+            <a:avLst>
+              <a:gd name="adj" fmla="val 14000"/>
+            </a:avLst>
+          </a:prstGeom>
+          <a:solidFill>
+            <a:srgbClr val="FFFFFF"/>
+          </a:solidFill>
+          <a:ln w="12700">
+            <a:solidFill>
+              <a:srgbClr val="8FAADC"/>
+            </a:solidFill>
+          </a:ln>
+          <a:effectLst/>
+        </p:spPr>
+        <p:style>
+          <a:lnRef idx="1">
+            <a:schemeClr val="accent1"/>
+          </a:lnRef>
+          <a:fillRef idx="3">
+            <a:schemeClr val="accent1"/>
+          </a:fillRef>
+          <a:effectRef idx="2">
+            <a:schemeClr val="accent1"/>
+          </a:effectRef>
+          <a:fontRef idx="minor">
+            <a:schemeClr val="lt1"/>
+          </a:fontRef>
+        </p:style>
+        <p:txBody>
+          <a:bodyPr rtlCol="0" anchor="ctr" wrap="square" lIns="25400" rIns="25400" tIns="0" bIns="0"/>
+          <a:lstStyle/>
+          <a:p>
+            <a:pPr algn="ctr"/>
+            <a:r>
+              <a:rPr sz="950" b="0">
+                <a:solidFill>
+                  <a:srgbClr val="1F3864"/>
+                </a:solidFill>
+              </a:rPr>
+              <a:t>Hogar</a:t>
+            </a:r>
+          </a:p>
+        </p:txBody>
+      </p:sp>
       <p:cxnSp>
         <p:nvCxnSpPr>
-          <p:cNvPr id="47" name="Conector: angular 46">
-            <a:extLst>
-              <a:ext uri="{FF2B5EF4-FFF2-40B4-BE49-F238E27FC236}">
-                <a16:creationId xmlns:a16="http://schemas.microsoft.com/office/drawing/2014/main" id="{8DC0B735-3B88-F170-9C1C-8EDC5222E4F7}"/>
-              </a:ext>
-            </a:extLst>
-          </p:cNvPr>
-          <p:cNvCxnSpPr>
-            <a:stCxn id="4" idx="2"/>
-            <a:endCxn id="9" idx="0"/>
-          </p:cNvCxnSpPr>
+          <p:cNvPr id="36" name="Connector 35"/>
+          <p:cNvCxnSpPr/>
           <p:nvPr/>
         </p:nvCxnSpPr>
         <p:spPr>
-          <a:xfrm rot="16200000" flipH="1">
-            <a:off x="6380863" y="1318639"/>
-            <a:ext cx="389419" cy="959144"/>
-          </a:xfrm>
-          <a:prstGeom prst="bentConnector3">
+          <a:xfrm>
+            <a:off x="4448556" y="1353312"/>
+            <a:ext cx="0" cy="2926080"/>
+          </a:xfrm>
+          <a:prstGeom prst="line">
             <a:avLst/>
           </a:prstGeom>
-          <a:ln>
-            <a:headEnd type="triangle"/>
-            <a:tailEnd type="triangle"/>
+          <a:ln w="9525">
+            <a:solidFill>
+              <a:srgbClr val="8FAADC"/>
+            </a:solidFill>
+            <a:tailEnd type="triangle" w="sm" len="sm"/>
           </a:ln>
         </p:spPr>
         <p:style>
@@ -5520,32 +4978,81 @@
           </a:fontRef>
         </p:style>
       </p:cxnSp>
+      <p:sp>
+        <p:nvSpPr>
+          <p:cNvPr id="37" name="Rounded Rectangle 36"/>
+          <p:cNvSpPr/>
+          <p:nvPr/>
+        </p:nvSpPr>
+        <p:spPr>
+          <a:xfrm>
+            <a:off x="5358384" y="896112"/>
+            <a:ext cx="1600200" cy="457200"/>
+          </a:xfrm>
+          <a:prstGeom prst="roundRect">
+            <a:avLst>
+              <a:gd name="adj" fmla="val 14000"/>
+            </a:avLst>
+          </a:prstGeom>
+          <a:solidFill>
+            <a:srgbClr val="1F4E79"/>
+          </a:solidFill>
+          <a:ln w="12700">
+            <a:solidFill>
+              <a:srgbClr val="1F4E79"/>
+            </a:solidFill>
+          </a:ln>
+          <a:effectLst/>
+        </p:spPr>
+        <p:style>
+          <a:lnRef idx="1">
+            <a:schemeClr val="accent1"/>
+          </a:lnRef>
+          <a:fillRef idx="3">
+            <a:schemeClr val="accent1"/>
+          </a:fillRef>
+          <a:effectRef idx="2">
+            <a:schemeClr val="accent1"/>
+          </a:effectRef>
+          <a:fontRef idx="minor">
+            <a:schemeClr val="lt1"/>
+          </a:fontRef>
+        </p:style>
+        <p:txBody>
+          <a:bodyPr rtlCol="0" anchor="ctr" wrap="square" lIns="25400" rIns="25400" tIns="0" bIns="0"/>
+          <a:lstStyle/>
+          <a:p>
+            <a:pPr algn="ctr"/>
+            <a:r>
+              <a:rPr sz="1100" b="1">
+                <a:solidFill>
+                  <a:srgbClr val="FFFFFF"/>
+                </a:solidFill>
+              </a:rPr>
+              <a:t>Favoritos</a:t>
+            </a:r>
+          </a:p>
+        </p:txBody>
+      </p:sp>
       <p:cxnSp>
         <p:nvCxnSpPr>
-          <p:cNvPr id="49" name="Conector: angular 48">
-            <a:extLst>
-              <a:ext uri="{FF2B5EF4-FFF2-40B4-BE49-F238E27FC236}">
-                <a16:creationId xmlns:a16="http://schemas.microsoft.com/office/drawing/2014/main" id="{DE2E9D97-CB71-2B7F-65CD-B4F6C700CBA4}"/>
-              </a:ext>
-            </a:extLst>
-          </p:cNvPr>
-          <p:cNvCxnSpPr>
-            <a:stCxn id="4" idx="2"/>
-            <a:endCxn id="15" idx="0"/>
-          </p:cNvCxnSpPr>
+          <p:cNvPr id="38" name="Connector 37"/>
+          <p:cNvCxnSpPr/>
           <p:nvPr/>
         </p:nvCxnSpPr>
         <p:spPr>
-          <a:xfrm rot="16200000" flipH="1">
-            <a:off x="7202765" y="496737"/>
-            <a:ext cx="389419" cy="2602948"/>
-          </a:xfrm>
-          <a:prstGeom prst="bentConnector3">
+          <a:xfrm>
+            <a:off x="6158484" y="704088"/>
+            <a:ext cx="0" cy="192024"/>
+          </a:xfrm>
+          <a:prstGeom prst="line">
             <a:avLst/>
           </a:prstGeom>
-          <a:ln>
-            <a:headEnd type="triangle"/>
-            <a:tailEnd type="triangle"/>
+          <a:ln w="9525">
+            <a:solidFill>
+              <a:srgbClr val="BDD7EE"/>
+            </a:solidFill>
+            <a:tailEnd type="triangle" w="sm" len="sm"/>
           </a:ln>
         </p:spPr>
         <p:style>
@@ -5563,32 +5070,81 @@
           </a:fontRef>
         </p:style>
       </p:cxnSp>
+      <p:sp>
+        <p:nvSpPr>
+          <p:cNvPr id="39" name="Rounded Rectangle 38"/>
+          <p:cNvSpPr/>
+          <p:nvPr/>
+        </p:nvSpPr>
+        <p:spPr>
+          <a:xfrm>
+            <a:off x="5358384" y="1536192"/>
+            <a:ext cx="1600200" cy="365760"/>
+          </a:xfrm>
+          <a:prstGeom prst="roundRect">
+            <a:avLst>
+              <a:gd name="adj" fmla="val 14000"/>
+            </a:avLst>
+          </a:prstGeom>
+          <a:solidFill>
+            <a:srgbClr val="FFFFFF"/>
+          </a:solidFill>
+          <a:ln w="12700">
+            <a:solidFill>
+              <a:srgbClr val="8FAADC"/>
+            </a:solidFill>
+          </a:ln>
+          <a:effectLst/>
+        </p:spPr>
+        <p:style>
+          <a:lnRef idx="1">
+            <a:schemeClr val="accent1"/>
+          </a:lnRef>
+          <a:fillRef idx="3">
+            <a:schemeClr val="accent1"/>
+          </a:fillRef>
+          <a:effectRef idx="2">
+            <a:schemeClr val="accent1"/>
+          </a:effectRef>
+          <a:fontRef idx="minor">
+            <a:schemeClr val="lt1"/>
+          </a:fontRef>
+        </p:style>
+        <p:txBody>
+          <a:bodyPr rtlCol="0" anchor="ctr" wrap="square" lIns="25400" rIns="25400" tIns="0" bIns="0"/>
+          <a:lstStyle/>
+          <a:p>
+            <a:pPr algn="ctr"/>
+            <a:r>
+              <a:rPr sz="950" b="0">
+                <a:solidFill>
+                  <a:srgbClr val="1F3864"/>
+                </a:solidFill>
+              </a:rPr>
+              <a:t>Dispositivos favoritos</a:t>
+            </a:r>
+          </a:p>
+        </p:txBody>
+      </p:sp>
       <p:cxnSp>
         <p:nvCxnSpPr>
-          <p:cNvPr id="51" name="Conector: angular 50">
-            <a:extLst>
-              <a:ext uri="{FF2B5EF4-FFF2-40B4-BE49-F238E27FC236}">
-                <a16:creationId xmlns:a16="http://schemas.microsoft.com/office/drawing/2014/main" id="{FEFFFE87-3CC8-8B68-E96C-B6538F24FCB5}"/>
-              </a:ext>
-            </a:extLst>
-          </p:cNvPr>
-          <p:cNvCxnSpPr>
-            <a:stCxn id="4" idx="2"/>
-            <a:endCxn id="17" idx="0"/>
-          </p:cNvCxnSpPr>
+          <p:cNvPr id="40" name="Connector 39"/>
+          <p:cNvCxnSpPr/>
           <p:nvPr/>
         </p:nvCxnSpPr>
         <p:spPr>
-          <a:xfrm rot="16200000" flipH="1">
-            <a:off x="8041838" y="-342337"/>
-            <a:ext cx="389419" cy="4281095"/>
-          </a:xfrm>
-          <a:prstGeom prst="bentConnector3">
+          <a:xfrm>
+            <a:off x="6158484" y="1353312"/>
+            <a:ext cx="0" cy="182880"/>
+          </a:xfrm>
+          <a:prstGeom prst="line">
             <a:avLst/>
           </a:prstGeom>
-          <a:ln>
-            <a:headEnd type="triangle"/>
-            <a:tailEnd type="triangle"/>
+          <a:ln w="9525">
+            <a:solidFill>
+              <a:srgbClr val="8FAADC"/>
+            </a:solidFill>
+            <a:tailEnd type="triangle" w="sm" len="sm"/>
           </a:ln>
         </p:spPr>
         <p:style>
@@ -5606,32 +5162,81 @@
           </a:fontRef>
         </p:style>
       </p:cxnSp>
+      <p:sp>
+        <p:nvSpPr>
+          <p:cNvPr id="41" name="Rounded Rectangle 40"/>
+          <p:cNvSpPr/>
+          <p:nvPr/>
+        </p:nvSpPr>
+        <p:spPr>
+          <a:xfrm>
+            <a:off x="7068312" y="896112"/>
+            <a:ext cx="1600200" cy="457200"/>
+          </a:xfrm>
+          <a:prstGeom prst="roundRect">
+            <a:avLst>
+              <a:gd name="adj" fmla="val 14000"/>
+            </a:avLst>
+          </a:prstGeom>
+          <a:solidFill>
+            <a:srgbClr val="1F4E79"/>
+          </a:solidFill>
+          <a:ln w="12700">
+            <a:solidFill>
+              <a:srgbClr val="1F4E79"/>
+            </a:solidFill>
+          </a:ln>
+          <a:effectLst/>
+        </p:spPr>
+        <p:style>
+          <a:lnRef idx="1">
+            <a:schemeClr val="accent1"/>
+          </a:lnRef>
+          <a:fillRef idx="3">
+            <a:schemeClr val="accent1"/>
+          </a:fillRef>
+          <a:effectRef idx="2">
+            <a:schemeClr val="accent1"/>
+          </a:effectRef>
+          <a:fontRef idx="minor">
+            <a:schemeClr val="lt1"/>
+          </a:fontRef>
+        </p:style>
+        <p:txBody>
+          <a:bodyPr rtlCol="0" anchor="ctr" wrap="square" lIns="25400" rIns="25400" tIns="0" bIns="0"/>
+          <a:lstStyle/>
+          <a:p>
+            <a:pPr algn="ctr"/>
+            <a:r>
+              <a:rPr sz="1100" b="1">
+                <a:solidFill>
+                  <a:srgbClr val="FFFFFF"/>
+                </a:solidFill>
+              </a:rPr>
+              <a:t>Notificaciones</a:t>
+            </a:r>
+          </a:p>
+        </p:txBody>
+      </p:sp>
       <p:cxnSp>
         <p:nvCxnSpPr>
-          <p:cNvPr id="53" name="Conector recto de flecha 52">
-            <a:extLst>
-              <a:ext uri="{FF2B5EF4-FFF2-40B4-BE49-F238E27FC236}">
-                <a16:creationId xmlns:a16="http://schemas.microsoft.com/office/drawing/2014/main" id="{7B2617B4-AC9F-03B6-E240-CC1BC866DC2E}"/>
-              </a:ext>
-            </a:extLst>
-          </p:cNvPr>
-          <p:cNvCxnSpPr>
-            <a:stCxn id="36" idx="2"/>
-            <a:endCxn id="4" idx="0"/>
-          </p:cNvCxnSpPr>
+          <p:cNvPr id="42" name="Connector 41"/>
+          <p:cNvCxnSpPr/>
           <p:nvPr/>
         </p:nvCxnSpPr>
         <p:spPr>
           <a:xfrm>
-            <a:off x="6096000" y="996833"/>
-            <a:ext cx="0" cy="278423"/>
-          </a:xfrm>
-          <a:prstGeom prst="straightConnector1">
+            <a:off x="7868412" y="704088"/>
+            <a:ext cx="0" cy="192024"/>
+          </a:xfrm>
+          <a:prstGeom prst="line">
             <a:avLst/>
           </a:prstGeom>
-          <a:ln>
-            <a:headEnd type="triangle"/>
-            <a:tailEnd type="triangle"/>
+          <a:ln w="9525">
+            <a:solidFill>
+              <a:srgbClr val="BDD7EE"/>
+            </a:solidFill>
+            <a:tailEnd type="triangle" w="sm" len="sm"/>
           </a:ln>
         </p:spPr>
         <p:style>
@@ -5649,6 +5254,982 @@
           </a:fontRef>
         </p:style>
       </p:cxnSp>
+      <p:sp>
+        <p:nvSpPr>
+          <p:cNvPr id="43" name="Rounded Rectangle 42"/>
+          <p:cNvSpPr/>
+          <p:nvPr/>
+        </p:nvSpPr>
+        <p:spPr>
+          <a:xfrm>
+            <a:off x="7068312" y="1536192"/>
+            <a:ext cx="1600200" cy="365760"/>
+          </a:xfrm>
+          <a:prstGeom prst="roundRect">
+            <a:avLst>
+              <a:gd name="adj" fmla="val 14000"/>
+            </a:avLst>
+          </a:prstGeom>
+          <a:solidFill>
+            <a:srgbClr val="FFFFFF"/>
+          </a:solidFill>
+          <a:ln w="12700">
+            <a:solidFill>
+              <a:srgbClr val="8FAADC"/>
+            </a:solidFill>
+          </a:ln>
+          <a:effectLst/>
+        </p:spPr>
+        <p:style>
+          <a:lnRef idx="1">
+            <a:schemeClr val="accent1"/>
+          </a:lnRef>
+          <a:fillRef idx="3">
+            <a:schemeClr val="accent1"/>
+          </a:fillRef>
+          <a:effectRef idx="2">
+            <a:schemeClr val="accent1"/>
+          </a:effectRef>
+          <a:fontRef idx="minor">
+            <a:schemeClr val="lt1"/>
+          </a:fontRef>
+        </p:style>
+        <p:txBody>
+          <a:bodyPr rtlCol="0" anchor="ctr" wrap="square" lIns="25400" rIns="25400" tIns="0" bIns="0"/>
+          <a:lstStyle/>
+          <a:p>
+            <a:pPr algn="ctr"/>
+            <a:r>
+              <a:rPr sz="950" b="0">
+                <a:solidFill>
+                  <a:srgbClr val="1F3864"/>
+                </a:solidFill>
+              </a:rPr>
+              <a:t>Alertas</a:t>
+            </a:r>
+          </a:p>
+        </p:txBody>
+      </p:sp>
+      <p:cxnSp>
+        <p:nvCxnSpPr>
+          <p:cNvPr id="44" name="Connector 43"/>
+          <p:cNvCxnSpPr/>
+          <p:nvPr/>
+        </p:nvCxnSpPr>
+        <p:spPr>
+          <a:xfrm>
+            <a:off x="7868412" y="1353312"/>
+            <a:ext cx="0" cy="182880"/>
+          </a:xfrm>
+          <a:prstGeom prst="line">
+            <a:avLst/>
+          </a:prstGeom>
+          <a:ln w="9525">
+            <a:solidFill>
+              <a:srgbClr val="8FAADC"/>
+            </a:solidFill>
+            <a:tailEnd type="triangle" w="sm" len="sm"/>
+          </a:ln>
+        </p:spPr>
+        <p:style>
+          <a:lnRef idx="2">
+            <a:schemeClr val="accent1"/>
+          </a:lnRef>
+          <a:fillRef idx="0">
+            <a:schemeClr val="accent1"/>
+          </a:fillRef>
+          <a:effectRef idx="1">
+            <a:schemeClr val="accent1"/>
+          </a:effectRef>
+          <a:fontRef idx="minor">
+            <a:schemeClr val="tx1"/>
+          </a:fontRef>
+        </p:style>
+      </p:cxnSp>
+      <p:sp>
+        <p:nvSpPr>
+          <p:cNvPr id="45" name="Rounded Rectangle 44"/>
+          <p:cNvSpPr/>
+          <p:nvPr/>
+        </p:nvSpPr>
+        <p:spPr>
+          <a:xfrm>
+            <a:off x="7068312" y="1993391"/>
+            <a:ext cx="1600200" cy="365760"/>
+          </a:xfrm>
+          <a:prstGeom prst="roundRect">
+            <a:avLst>
+              <a:gd name="adj" fmla="val 14000"/>
+            </a:avLst>
+          </a:prstGeom>
+          <a:solidFill>
+            <a:srgbClr val="FFFFFF"/>
+          </a:solidFill>
+          <a:ln w="12700">
+            <a:solidFill>
+              <a:srgbClr val="8FAADC"/>
+            </a:solidFill>
+          </a:ln>
+          <a:effectLst/>
+        </p:spPr>
+        <p:style>
+          <a:lnRef idx="1">
+            <a:schemeClr val="accent1"/>
+          </a:lnRef>
+          <a:fillRef idx="3">
+            <a:schemeClr val="accent1"/>
+          </a:fillRef>
+          <a:effectRef idx="2">
+            <a:schemeClr val="accent1"/>
+          </a:effectRef>
+          <a:fontRef idx="minor">
+            <a:schemeClr val="lt1"/>
+          </a:fontRef>
+        </p:style>
+        <p:txBody>
+          <a:bodyPr rtlCol="0" anchor="ctr" wrap="square" lIns="25400" rIns="25400" tIns="0" bIns="0"/>
+          <a:lstStyle/>
+          <a:p>
+            <a:pPr algn="ctr"/>
+            <a:r>
+              <a:rPr sz="950" b="0">
+                <a:solidFill>
+                  <a:srgbClr val="1F3864"/>
+                </a:solidFill>
+              </a:rPr>
+              <a:t>Recomendaciones</a:t>
+            </a:r>
+          </a:p>
+        </p:txBody>
+      </p:sp>
+      <p:cxnSp>
+        <p:nvCxnSpPr>
+          <p:cNvPr id="46" name="Connector 45"/>
+          <p:cNvCxnSpPr/>
+          <p:nvPr/>
+        </p:nvCxnSpPr>
+        <p:spPr>
+          <a:xfrm>
+            <a:off x="7868412" y="1353312"/>
+            <a:ext cx="0" cy="640079"/>
+          </a:xfrm>
+          <a:prstGeom prst="line">
+            <a:avLst/>
+          </a:prstGeom>
+          <a:ln w="9525">
+            <a:solidFill>
+              <a:srgbClr val="8FAADC"/>
+            </a:solidFill>
+            <a:tailEnd type="triangle" w="sm" len="sm"/>
+          </a:ln>
+        </p:spPr>
+        <p:style>
+          <a:lnRef idx="2">
+            <a:schemeClr val="accent1"/>
+          </a:lnRef>
+          <a:fillRef idx="0">
+            <a:schemeClr val="accent1"/>
+          </a:fillRef>
+          <a:effectRef idx="1">
+            <a:schemeClr val="accent1"/>
+          </a:effectRef>
+          <a:fontRef idx="minor">
+            <a:schemeClr val="tx1"/>
+          </a:fontRef>
+        </p:style>
+      </p:cxnSp>
+      <p:sp>
+        <p:nvSpPr>
+          <p:cNvPr id="47" name="Rounded Rectangle 46"/>
+          <p:cNvSpPr/>
+          <p:nvPr/>
+        </p:nvSpPr>
+        <p:spPr>
+          <a:xfrm>
+            <a:off x="8778240" y="896112"/>
+            <a:ext cx="1600200" cy="457200"/>
+          </a:xfrm>
+          <a:prstGeom prst="roundRect">
+            <a:avLst>
+              <a:gd name="adj" fmla="val 14000"/>
+            </a:avLst>
+          </a:prstGeom>
+          <a:solidFill>
+            <a:srgbClr val="1F4E79"/>
+          </a:solidFill>
+          <a:ln w="12700">
+            <a:solidFill>
+              <a:srgbClr val="1F4E79"/>
+            </a:solidFill>
+          </a:ln>
+          <a:effectLst/>
+        </p:spPr>
+        <p:style>
+          <a:lnRef idx="1">
+            <a:schemeClr val="accent1"/>
+          </a:lnRef>
+          <a:fillRef idx="3">
+            <a:schemeClr val="accent1"/>
+          </a:fillRef>
+          <a:effectRef idx="2">
+            <a:schemeClr val="accent1"/>
+          </a:effectRef>
+          <a:fontRef idx="minor">
+            <a:schemeClr val="lt1"/>
+          </a:fontRef>
+        </p:style>
+        <p:txBody>
+          <a:bodyPr rtlCol="0" anchor="ctr" wrap="square" lIns="25400" rIns="25400" tIns="0" bIns="0"/>
+          <a:lstStyle/>
+          <a:p>
+            <a:pPr algn="ctr"/>
+            <a:r>
+              <a:rPr sz="1100" b="1">
+                <a:solidFill>
+                  <a:srgbClr val="FFFFFF"/>
+                </a:solidFill>
+              </a:rPr>
+              <a:t>Ajustes</a:t>
+            </a:r>
+          </a:p>
+        </p:txBody>
+      </p:sp>
+      <p:cxnSp>
+        <p:nvCxnSpPr>
+          <p:cNvPr id="48" name="Connector 47"/>
+          <p:cNvCxnSpPr/>
+          <p:nvPr/>
+        </p:nvCxnSpPr>
+        <p:spPr>
+          <a:xfrm>
+            <a:off x="9578340" y="704088"/>
+            <a:ext cx="0" cy="192024"/>
+          </a:xfrm>
+          <a:prstGeom prst="line">
+            <a:avLst/>
+          </a:prstGeom>
+          <a:ln w="9525">
+            <a:solidFill>
+              <a:srgbClr val="BDD7EE"/>
+            </a:solidFill>
+            <a:tailEnd type="triangle" w="sm" len="sm"/>
+          </a:ln>
+        </p:spPr>
+        <p:style>
+          <a:lnRef idx="2">
+            <a:schemeClr val="accent1"/>
+          </a:lnRef>
+          <a:fillRef idx="0">
+            <a:schemeClr val="accent1"/>
+          </a:fillRef>
+          <a:effectRef idx="1">
+            <a:schemeClr val="accent1"/>
+          </a:effectRef>
+          <a:fontRef idx="minor">
+            <a:schemeClr val="tx1"/>
+          </a:fontRef>
+        </p:style>
+      </p:cxnSp>
+      <p:sp>
+        <p:nvSpPr>
+          <p:cNvPr id="49" name="Rounded Rectangle 48"/>
+          <p:cNvSpPr/>
+          <p:nvPr/>
+        </p:nvSpPr>
+        <p:spPr>
+          <a:xfrm>
+            <a:off x="8778240" y="1536192"/>
+            <a:ext cx="1600200" cy="365760"/>
+          </a:xfrm>
+          <a:prstGeom prst="roundRect">
+            <a:avLst>
+              <a:gd name="adj" fmla="val 14000"/>
+            </a:avLst>
+          </a:prstGeom>
+          <a:solidFill>
+            <a:srgbClr val="FFFFFF"/>
+          </a:solidFill>
+          <a:ln w="12700">
+            <a:solidFill>
+              <a:srgbClr val="8FAADC"/>
+            </a:solidFill>
+          </a:ln>
+          <a:effectLst/>
+        </p:spPr>
+        <p:style>
+          <a:lnRef idx="1">
+            <a:schemeClr val="accent1"/>
+          </a:lnRef>
+          <a:fillRef idx="3">
+            <a:schemeClr val="accent1"/>
+          </a:fillRef>
+          <a:effectRef idx="2">
+            <a:schemeClr val="accent1"/>
+          </a:effectRef>
+          <a:fontRef idx="minor">
+            <a:schemeClr val="lt1"/>
+          </a:fontRef>
+        </p:style>
+        <p:txBody>
+          <a:bodyPr rtlCol="0" anchor="ctr" wrap="square" lIns="25400" rIns="25400" tIns="0" bIns="0"/>
+          <a:lstStyle/>
+          <a:p>
+            <a:pPr algn="ctr"/>
+            <a:r>
+              <a:rPr sz="950" b="0">
+                <a:solidFill>
+                  <a:srgbClr val="1F3864"/>
+                </a:solidFill>
+              </a:rPr>
+              <a:t>Idioma</a:t>
+            </a:r>
+          </a:p>
+        </p:txBody>
+      </p:sp>
+      <p:cxnSp>
+        <p:nvCxnSpPr>
+          <p:cNvPr id="50" name="Connector 49"/>
+          <p:cNvCxnSpPr/>
+          <p:nvPr/>
+        </p:nvCxnSpPr>
+        <p:spPr>
+          <a:xfrm>
+            <a:off x="9578340" y="1353312"/>
+            <a:ext cx="0" cy="182880"/>
+          </a:xfrm>
+          <a:prstGeom prst="line">
+            <a:avLst/>
+          </a:prstGeom>
+          <a:ln w="9525">
+            <a:solidFill>
+              <a:srgbClr val="8FAADC"/>
+            </a:solidFill>
+            <a:tailEnd type="triangle" w="sm" len="sm"/>
+          </a:ln>
+        </p:spPr>
+        <p:style>
+          <a:lnRef idx="2">
+            <a:schemeClr val="accent1"/>
+          </a:lnRef>
+          <a:fillRef idx="0">
+            <a:schemeClr val="accent1"/>
+          </a:fillRef>
+          <a:effectRef idx="1">
+            <a:schemeClr val="accent1"/>
+          </a:effectRef>
+          <a:fontRef idx="minor">
+            <a:schemeClr val="tx1"/>
+          </a:fontRef>
+        </p:style>
+      </p:cxnSp>
+      <p:sp>
+        <p:nvSpPr>
+          <p:cNvPr id="51" name="Rounded Rectangle 50"/>
+          <p:cNvSpPr/>
+          <p:nvPr/>
+        </p:nvSpPr>
+        <p:spPr>
+          <a:xfrm>
+            <a:off x="8778240" y="1993391"/>
+            <a:ext cx="1600200" cy="365760"/>
+          </a:xfrm>
+          <a:prstGeom prst="roundRect">
+            <a:avLst>
+              <a:gd name="adj" fmla="val 14000"/>
+            </a:avLst>
+          </a:prstGeom>
+          <a:solidFill>
+            <a:srgbClr val="FFFFFF"/>
+          </a:solidFill>
+          <a:ln w="12700">
+            <a:solidFill>
+              <a:srgbClr val="8FAADC"/>
+            </a:solidFill>
+          </a:ln>
+          <a:effectLst/>
+        </p:spPr>
+        <p:style>
+          <a:lnRef idx="1">
+            <a:schemeClr val="accent1"/>
+          </a:lnRef>
+          <a:fillRef idx="3">
+            <a:schemeClr val="accent1"/>
+          </a:fillRef>
+          <a:effectRef idx="2">
+            <a:schemeClr val="accent1"/>
+          </a:effectRef>
+          <a:fontRef idx="minor">
+            <a:schemeClr val="lt1"/>
+          </a:fontRef>
+        </p:style>
+        <p:txBody>
+          <a:bodyPr rtlCol="0" anchor="ctr" wrap="square" lIns="25400" rIns="25400" tIns="0" bIns="0"/>
+          <a:lstStyle/>
+          <a:p>
+            <a:pPr algn="ctr"/>
+            <a:r>
+              <a:rPr sz="950" b="0">
+                <a:solidFill>
+                  <a:srgbClr val="1F3864"/>
+                </a:solidFill>
+              </a:rPr>
+              <a:t>Temas (colores)</a:t>
+            </a:r>
+          </a:p>
+        </p:txBody>
+      </p:sp>
+      <p:cxnSp>
+        <p:nvCxnSpPr>
+          <p:cNvPr id="52" name="Connector 51"/>
+          <p:cNvCxnSpPr/>
+          <p:nvPr/>
+        </p:nvCxnSpPr>
+        <p:spPr>
+          <a:xfrm>
+            <a:off x="9578340" y="1353312"/>
+            <a:ext cx="0" cy="640079"/>
+          </a:xfrm>
+          <a:prstGeom prst="line">
+            <a:avLst/>
+          </a:prstGeom>
+          <a:ln w="9525">
+            <a:solidFill>
+              <a:srgbClr val="8FAADC"/>
+            </a:solidFill>
+            <a:tailEnd type="triangle" w="sm" len="sm"/>
+          </a:ln>
+        </p:spPr>
+        <p:style>
+          <a:lnRef idx="2">
+            <a:schemeClr val="accent1"/>
+          </a:lnRef>
+          <a:fillRef idx="0">
+            <a:schemeClr val="accent1"/>
+          </a:fillRef>
+          <a:effectRef idx="1">
+            <a:schemeClr val="accent1"/>
+          </a:effectRef>
+          <a:fontRef idx="minor">
+            <a:schemeClr val="tx1"/>
+          </a:fontRef>
+        </p:style>
+      </p:cxnSp>
+      <p:sp>
+        <p:nvSpPr>
+          <p:cNvPr id="53" name="Rounded Rectangle 52"/>
+          <p:cNvSpPr/>
+          <p:nvPr/>
+        </p:nvSpPr>
+        <p:spPr>
+          <a:xfrm>
+            <a:off x="8778240" y="2450591"/>
+            <a:ext cx="1600200" cy="365760"/>
+          </a:xfrm>
+          <a:prstGeom prst="roundRect">
+            <a:avLst>
+              <a:gd name="adj" fmla="val 14000"/>
+            </a:avLst>
+          </a:prstGeom>
+          <a:solidFill>
+            <a:srgbClr val="FFFFFF"/>
+          </a:solidFill>
+          <a:ln w="12700">
+            <a:solidFill>
+              <a:srgbClr val="8FAADC"/>
+            </a:solidFill>
+          </a:ln>
+          <a:effectLst/>
+        </p:spPr>
+        <p:style>
+          <a:lnRef idx="1">
+            <a:schemeClr val="accent1"/>
+          </a:lnRef>
+          <a:fillRef idx="3">
+            <a:schemeClr val="accent1"/>
+          </a:fillRef>
+          <a:effectRef idx="2">
+            <a:schemeClr val="accent1"/>
+          </a:effectRef>
+          <a:fontRef idx="minor">
+            <a:schemeClr val="lt1"/>
+          </a:fontRef>
+        </p:style>
+        <p:txBody>
+          <a:bodyPr rtlCol="0" anchor="ctr" wrap="square" lIns="25400" rIns="25400" tIns="0" bIns="0"/>
+          <a:lstStyle/>
+          <a:p>
+            <a:pPr algn="ctr"/>
+            <a:r>
+              <a:rPr sz="950" b="0">
+                <a:solidFill>
+                  <a:srgbClr val="1F3864"/>
+                </a:solidFill>
+              </a:rPr>
+              <a:t>Notificaciones</a:t>
+            </a:r>
+          </a:p>
+        </p:txBody>
+      </p:sp>
+      <p:cxnSp>
+        <p:nvCxnSpPr>
+          <p:cNvPr id="54" name="Connector 53"/>
+          <p:cNvCxnSpPr/>
+          <p:nvPr/>
+        </p:nvCxnSpPr>
+        <p:spPr>
+          <a:xfrm>
+            <a:off x="9578340" y="1353312"/>
+            <a:ext cx="0" cy="1097279"/>
+          </a:xfrm>
+          <a:prstGeom prst="line">
+            <a:avLst/>
+          </a:prstGeom>
+          <a:ln w="9525">
+            <a:solidFill>
+              <a:srgbClr val="8FAADC"/>
+            </a:solidFill>
+            <a:tailEnd type="triangle" w="sm" len="sm"/>
+          </a:ln>
+        </p:spPr>
+        <p:style>
+          <a:lnRef idx="2">
+            <a:schemeClr val="accent1"/>
+          </a:lnRef>
+          <a:fillRef idx="0">
+            <a:schemeClr val="accent1"/>
+          </a:fillRef>
+          <a:effectRef idx="1">
+            <a:schemeClr val="accent1"/>
+          </a:effectRef>
+          <a:fontRef idx="minor">
+            <a:schemeClr val="tx1"/>
+          </a:fontRef>
+        </p:style>
+      </p:cxnSp>
+      <p:sp>
+        <p:nvSpPr>
+          <p:cNvPr id="55" name="Rounded Rectangle 54"/>
+          <p:cNvSpPr/>
+          <p:nvPr/>
+        </p:nvSpPr>
+        <p:spPr>
+          <a:xfrm>
+            <a:off x="10488168" y="896112"/>
+            <a:ext cx="1600200" cy="457200"/>
+          </a:xfrm>
+          <a:prstGeom prst="roundRect">
+            <a:avLst>
+              <a:gd name="adj" fmla="val 14000"/>
+            </a:avLst>
+          </a:prstGeom>
+          <a:solidFill>
+            <a:srgbClr val="1F4E79"/>
+          </a:solidFill>
+          <a:ln w="12700">
+            <a:solidFill>
+              <a:srgbClr val="1F4E79"/>
+            </a:solidFill>
+          </a:ln>
+          <a:effectLst/>
+        </p:spPr>
+        <p:style>
+          <a:lnRef idx="1">
+            <a:schemeClr val="accent1"/>
+          </a:lnRef>
+          <a:fillRef idx="3">
+            <a:schemeClr val="accent1"/>
+          </a:fillRef>
+          <a:effectRef idx="2">
+            <a:schemeClr val="accent1"/>
+          </a:effectRef>
+          <a:fontRef idx="minor">
+            <a:schemeClr val="lt1"/>
+          </a:fontRef>
+        </p:style>
+        <p:txBody>
+          <a:bodyPr rtlCol="0" anchor="ctr" wrap="square" lIns="25400" rIns="25400" tIns="0" bIns="0"/>
+          <a:lstStyle/>
+          <a:p>
+            <a:pPr algn="ctr"/>
+            <a:r>
+              <a:rPr sz="1100" b="1">
+                <a:solidFill>
+                  <a:srgbClr val="FFFFFF"/>
+                </a:solidFill>
+              </a:rPr>
+              <a:t>Mi cuenta</a:t>
+            </a:r>
+          </a:p>
+        </p:txBody>
+      </p:sp>
+      <p:cxnSp>
+        <p:nvCxnSpPr>
+          <p:cNvPr id="56" name="Connector 55"/>
+          <p:cNvCxnSpPr/>
+          <p:nvPr/>
+        </p:nvCxnSpPr>
+        <p:spPr>
+          <a:xfrm>
+            <a:off x="11288268" y="704088"/>
+            <a:ext cx="0" cy="192024"/>
+          </a:xfrm>
+          <a:prstGeom prst="line">
+            <a:avLst/>
+          </a:prstGeom>
+          <a:ln w="9525">
+            <a:solidFill>
+              <a:srgbClr val="BDD7EE"/>
+            </a:solidFill>
+            <a:tailEnd type="triangle" w="sm" len="sm"/>
+          </a:ln>
+        </p:spPr>
+        <p:style>
+          <a:lnRef idx="2">
+            <a:schemeClr val="accent1"/>
+          </a:lnRef>
+          <a:fillRef idx="0">
+            <a:schemeClr val="accent1"/>
+          </a:fillRef>
+          <a:effectRef idx="1">
+            <a:schemeClr val="accent1"/>
+          </a:effectRef>
+          <a:fontRef idx="minor">
+            <a:schemeClr val="tx1"/>
+          </a:fontRef>
+        </p:style>
+      </p:cxnSp>
+      <p:sp>
+        <p:nvSpPr>
+          <p:cNvPr id="57" name="Rounded Rectangle 56"/>
+          <p:cNvSpPr/>
+          <p:nvPr/>
+        </p:nvSpPr>
+        <p:spPr>
+          <a:xfrm>
+            <a:off x="10488168" y="1536192"/>
+            <a:ext cx="1600200" cy="365760"/>
+          </a:xfrm>
+          <a:prstGeom prst="roundRect">
+            <a:avLst>
+              <a:gd name="adj" fmla="val 14000"/>
+            </a:avLst>
+          </a:prstGeom>
+          <a:solidFill>
+            <a:srgbClr val="FFFFFF"/>
+          </a:solidFill>
+          <a:ln w="12700">
+            <a:solidFill>
+              <a:srgbClr val="8FAADC"/>
+            </a:solidFill>
+          </a:ln>
+          <a:effectLst/>
+        </p:spPr>
+        <p:style>
+          <a:lnRef idx="1">
+            <a:schemeClr val="accent1"/>
+          </a:lnRef>
+          <a:fillRef idx="3">
+            <a:schemeClr val="accent1"/>
+          </a:fillRef>
+          <a:effectRef idx="2">
+            <a:schemeClr val="accent1"/>
+          </a:effectRef>
+          <a:fontRef idx="minor">
+            <a:schemeClr val="lt1"/>
+          </a:fontRef>
+        </p:style>
+        <p:txBody>
+          <a:bodyPr rtlCol="0" anchor="ctr" wrap="square" lIns="25400" rIns="25400" tIns="0" bIns="0"/>
+          <a:lstStyle/>
+          <a:p>
+            <a:pPr algn="ctr"/>
+            <a:r>
+              <a:rPr sz="950" b="0">
+                <a:solidFill>
+                  <a:srgbClr val="1F3864"/>
+                </a:solidFill>
+              </a:rPr>
+              <a:t>Editar perfil</a:t>
+            </a:r>
+          </a:p>
+        </p:txBody>
+      </p:sp>
+      <p:cxnSp>
+        <p:nvCxnSpPr>
+          <p:cNvPr id="58" name="Connector 57"/>
+          <p:cNvCxnSpPr/>
+          <p:nvPr/>
+        </p:nvCxnSpPr>
+        <p:spPr>
+          <a:xfrm>
+            <a:off x="11288268" y="1353312"/>
+            <a:ext cx="0" cy="182880"/>
+          </a:xfrm>
+          <a:prstGeom prst="line">
+            <a:avLst/>
+          </a:prstGeom>
+          <a:ln w="9525">
+            <a:solidFill>
+              <a:srgbClr val="8FAADC"/>
+            </a:solidFill>
+            <a:tailEnd type="triangle" w="sm" len="sm"/>
+          </a:ln>
+        </p:spPr>
+        <p:style>
+          <a:lnRef idx="2">
+            <a:schemeClr val="accent1"/>
+          </a:lnRef>
+          <a:fillRef idx="0">
+            <a:schemeClr val="accent1"/>
+          </a:fillRef>
+          <a:effectRef idx="1">
+            <a:schemeClr val="accent1"/>
+          </a:effectRef>
+          <a:fontRef idx="minor">
+            <a:schemeClr val="tx1"/>
+          </a:fontRef>
+        </p:style>
+      </p:cxnSp>
+      <p:sp>
+        <p:nvSpPr>
+          <p:cNvPr id="59" name="Rounded Rectangle 58"/>
+          <p:cNvSpPr/>
+          <p:nvPr/>
+        </p:nvSpPr>
+        <p:spPr>
+          <a:xfrm>
+            <a:off x="10488168" y="1993391"/>
+            <a:ext cx="1600200" cy="365760"/>
+          </a:xfrm>
+          <a:prstGeom prst="roundRect">
+            <a:avLst>
+              <a:gd name="adj" fmla="val 14000"/>
+            </a:avLst>
+          </a:prstGeom>
+          <a:solidFill>
+            <a:srgbClr val="FFFFFF"/>
+          </a:solidFill>
+          <a:ln w="12700">
+            <a:solidFill>
+              <a:srgbClr val="8FAADC"/>
+            </a:solidFill>
+          </a:ln>
+          <a:effectLst/>
+        </p:spPr>
+        <p:style>
+          <a:lnRef idx="1">
+            <a:schemeClr val="accent1"/>
+          </a:lnRef>
+          <a:fillRef idx="3">
+            <a:schemeClr val="accent1"/>
+          </a:fillRef>
+          <a:effectRef idx="2">
+            <a:schemeClr val="accent1"/>
+          </a:effectRef>
+          <a:fontRef idx="minor">
+            <a:schemeClr val="lt1"/>
+          </a:fontRef>
+        </p:style>
+        <p:txBody>
+          <a:bodyPr rtlCol="0" anchor="ctr" wrap="square" lIns="25400" rIns="25400" tIns="0" bIns="0"/>
+          <a:lstStyle/>
+          <a:p>
+            <a:pPr algn="ctr"/>
+            <a:r>
+              <a:rPr sz="950" b="0">
+                <a:solidFill>
+                  <a:srgbClr val="1F3864"/>
+                </a:solidFill>
+              </a:rPr>
+              <a:t>Cambiar contraseña</a:t>
+            </a:r>
+          </a:p>
+        </p:txBody>
+      </p:sp>
+      <p:cxnSp>
+        <p:nvCxnSpPr>
+          <p:cNvPr id="60" name="Connector 59"/>
+          <p:cNvCxnSpPr/>
+          <p:nvPr/>
+        </p:nvCxnSpPr>
+        <p:spPr>
+          <a:xfrm>
+            <a:off x="11288268" y="1353312"/>
+            <a:ext cx="0" cy="640079"/>
+          </a:xfrm>
+          <a:prstGeom prst="line">
+            <a:avLst/>
+          </a:prstGeom>
+          <a:ln w="9525">
+            <a:solidFill>
+              <a:srgbClr val="8FAADC"/>
+            </a:solidFill>
+            <a:tailEnd type="triangle" w="sm" len="sm"/>
+          </a:ln>
+        </p:spPr>
+        <p:style>
+          <a:lnRef idx="2">
+            <a:schemeClr val="accent1"/>
+          </a:lnRef>
+          <a:fillRef idx="0">
+            <a:schemeClr val="accent1"/>
+          </a:fillRef>
+          <a:effectRef idx="1">
+            <a:schemeClr val="accent1"/>
+          </a:effectRef>
+          <a:fontRef idx="minor">
+            <a:schemeClr val="tx1"/>
+          </a:fontRef>
+        </p:style>
+      </p:cxnSp>
+      <p:sp>
+        <p:nvSpPr>
+          <p:cNvPr id="61" name="Rounded Rectangle 60"/>
+          <p:cNvSpPr/>
+          <p:nvPr/>
+        </p:nvSpPr>
+        <p:spPr>
+          <a:xfrm>
+            <a:off x="10488168" y="2450591"/>
+            <a:ext cx="1600200" cy="365760"/>
+          </a:xfrm>
+          <a:prstGeom prst="roundRect">
+            <a:avLst>
+              <a:gd name="adj" fmla="val 14000"/>
+            </a:avLst>
+          </a:prstGeom>
+          <a:solidFill>
+            <a:srgbClr val="FFFFFF"/>
+          </a:solidFill>
+          <a:ln w="12700">
+            <a:solidFill>
+              <a:srgbClr val="8FAADC"/>
+            </a:solidFill>
+          </a:ln>
+          <a:effectLst/>
+        </p:spPr>
+        <p:style>
+          <a:lnRef idx="1">
+            <a:schemeClr val="accent1"/>
+          </a:lnRef>
+          <a:fillRef idx="3">
+            <a:schemeClr val="accent1"/>
+          </a:fillRef>
+          <a:effectRef idx="2">
+            <a:schemeClr val="accent1"/>
+          </a:effectRef>
+          <a:fontRef idx="minor">
+            <a:schemeClr val="lt1"/>
+          </a:fontRef>
+        </p:style>
+        <p:txBody>
+          <a:bodyPr rtlCol="0" anchor="ctr" wrap="square" lIns="25400" rIns="25400" tIns="0" bIns="0"/>
+          <a:lstStyle/>
+          <a:p>
+            <a:pPr algn="ctr"/>
+            <a:r>
+              <a:rPr sz="950" b="0">
+                <a:solidFill>
+                  <a:srgbClr val="1F3864"/>
+                </a:solidFill>
+              </a:rPr>
+              <a:t>Cerrar sesión</a:t>
+            </a:r>
+          </a:p>
+        </p:txBody>
+      </p:sp>
+      <p:cxnSp>
+        <p:nvCxnSpPr>
+          <p:cNvPr id="62" name="Connector 61"/>
+          <p:cNvCxnSpPr/>
+          <p:nvPr/>
+        </p:nvCxnSpPr>
+        <p:spPr>
+          <a:xfrm>
+            <a:off x="11288268" y="1353312"/>
+            <a:ext cx="0" cy="1097279"/>
+          </a:xfrm>
+          <a:prstGeom prst="line">
+            <a:avLst/>
+          </a:prstGeom>
+          <a:ln w="9525">
+            <a:solidFill>
+              <a:srgbClr val="8FAADC"/>
+            </a:solidFill>
+            <a:tailEnd type="triangle" w="sm" len="sm"/>
+          </a:ln>
+        </p:spPr>
+        <p:style>
+          <a:lnRef idx="2">
+            <a:schemeClr val="accent1"/>
+          </a:lnRef>
+          <a:fillRef idx="0">
+            <a:schemeClr val="accent1"/>
+          </a:fillRef>
+          <a:effectRef idx="1">
+            <a:schemeClr val="accent1"/>
+          </a:effectRef>
+          <a:fontRef idx="minor">
+            <a:schemeClr val="tx1"/>
+          </a:fontRef>
+        </p:style>
+      </p:cxnSp>
+      <p:sp>
+        <p:nvSpPr>
+          <p:cNvPr id="63" name="Rounded Rectangle 62"/>
+          <p:cNvSpPr/>
+          <p:nvPr/>
+        </p:nvSpPr>
+        <p:spPr>
+          <a:xfrm>
+            <a:off x="228600" y="5029200"/>
+            <a:ext cx="11704320" cy="457200"/>
+          </a:xfrm>
+          <a:prstGeom prst="roundRect">
+            <a:avLst>
+              <a:gd name="adj" fmla="val 14000"/>
+            </a:avLst>
+          </a:prstGeom>
+          <a:solidFill>
+            <a:srgbClr val="FDEAEA"/>
+          </a:solidFill>
+          <a:ln w="12700">
+            <a:solidFill>
+              <a:srgbClr val="C00000"/>
+            </a:solidFill>
+          </a:ln>
+          <a:effectLst/>
+        </p:spPr>
+        <p:style>
+          <a:lnRef idx="1">
+            <a:schemeClr val="accent1"/>
+          </a:lnRef>
+          <a:fillRef idx="3">
+            <a:schemeClr val="accent1"/>
+          </a:fillRef>
+          <a:effectRef idx="2">
+            <a:schemeClr val="accent1"/>
+          </a:effectRef>
+          <a:fontRef idx="minor">
+            <a:schemeClr val="lt1"/>
+          </a:fontRef>
+        </p:style>
+        <p:txBody>
+          <a:bodyPr rtlCol="0" anchor="ctr" wrap="square" lIns="25400" rIns="25400" tIns="0" bIns="0"/>
+          <a:lstStyle/>
+          <a:p>
+            <a:pPr algn="ctr"/>
+            <a:r>
+              <a:rPr sz="1000" b="1">
+                <a:solidFill>
+                  <a:srgbClr val="C00000"/>
+                </a:solidFill>
+              </a:rPr>
+              <a:t>Las pantallas en rojo son accesibles únicamente por el propietario del hogar (usuario responsable).</a:t>
+            </a:r>
+          </a:p>
+        </p:txBody>
+      </p:sp>
     </p:spTree>
     <p:extLst>
       <p:ext uri="{BB962C8B-B14F-4D97-AF65-F5344CB8AC3E}">

</xml_diff>